<commit_message>
Submission: honest sandbox framing, Panta feature table, live data in chat, broad 'any debate' message; deck rebuilt; README/.env/GO-LIVE note on PANTA_READ_KEY
</commit_message>
<xml_diff>
--- a/submission/pot-pitch-deck.pptx
+++ b/submission/pot-pitch-deck.pptx
@@ -4,9 +4,6 @@
   <p:sldMasterIdLst>
     <p:sldMasterId id="2147483648" r:id="rId1"/>
   </p:sldMasterIdLst>
-  <p:notesMasterIdLst>
-    <p:notesMasterId r:id="rId12"/>
-  </p:notesMasterIdLst>
   <p:sldIdLst>
     <p:sldId id="256" r:id="rId2"/>
     <p:sldId id="257" r:id="rId3"/>
@@ -19,6 +16,9 @@
     <p:sldId id="264" r:id="rId10"/>
     <p:sldId id="265" r:id="rId11"/>
   </p:sldIdLst>
+  <p:notesMasterIdLst>
+    <p:notesMasterId r:id="rId12"/>
+  </p:notesMasterIdLst>
   <p:sldSz cx="12191695" cy="6858000"/>
   <p:notesSz cx="6858000" cy="12191695"/>
   <p:defaultTextStyle>
@@ -2004,8 +2004,8 @@
         </p:nvSpPr>
         <p:spPr>
           <a:xfrm>
-            <a:off x="548640" y="4023360"/>
-            <a:ext cx="6035040" cy="914400"/>
+            <a:off x="548640" y="3931920"/>
+            <a:ext cx="6217920" cy="1188720"/>
           </a:xfrm>
           <a:prstGeom prst="rect">
             <a:avLst/>
@@ -2021,7 +2021,7 @@
               <a:buNone/>
             </a:pPr>
             <a:r>
-              <a:rPr lang="en-US" sz="1600" dirty="0">
+              <a:rPr lang="en-US" sz="1500" dirty="0">
                 <a:solidFill>
                   <a:srgbClr val="F2F2F2"/>
                 </a:solidFill>
@@ -2029,9 +2029,9 @@
                 <a:ea typeface="Raleway" pitchFamily="34" charset="-122"/>
                 <a:cs typeface="Raleway" pitchFamily="34" charset="-120"/>
               </a:rPr>
-              <a:t>Telegram groups turn their arguments into Panta markets, back a side from their phones, and get a receipt when they settle.</a:t>
-            </a:r>
-            <a:endParaRPr lang="en-US" sz="1600" dirty="0"/>
+              <a:t>Any debate in a group chat becomes a Panta market: BBNaija, elections, celebrity news, movies, music drops and streams, football. Members back a side from their phones and get a receipt when it settles.</a:t>
+            </a:r>
+            <a:endParaRPr lang="en-US" sz="1500" dirty="0"/>
           </a:p>
         </p:txBody>
       </p:sp>
@@ -2184,6 +2184,9 @@
               </a:rPr>
               <a:t>POT</a:t>
             </a:r>
+            <a:pPr indent="0" marL="0">
+              <a:buNone/>
+            </a:pPr>
             <a:r>
               <a:rPr lang="en-US" sz="1100" dirty="0">
                 <a:solidFill>
@@ -2394,6 +2397,9 @@
               </a:rPr>
               <a:t>What's </a:t>
             </a:r>
+            <a:pPr indent="0" marL="0">
+              <a:buNone/>
+            </a:pPr>
             <a:r>
               <a:rPr lang="en-US" sz="3400" dirty="0">
                 <a:solidFill>
@@ -2779,6 +2785,9 @@
               </a:rPr>
               <a:t>Try it: </a:t>
             </a:r>
+            <a:pPr indent="0" marL="0">
+              <a:buNone/>
+            </a:pPr>
             <a:r>
               <a:rPr lang="en-US" sz="1600" dirty="0">
                 <a:solidFill>
@@ -2900,6 +2909,9 @@
               </a:rPr>
               <a:t>POT</a:t>
             </a:r>
+            <a:pPr indent="0" marL="0">
+              <a:buNone/>
+            </a:pPr>
             <a:r>
               <a:rPr lang="en-US" sz="1100" dirty="0">
                 <a:solidFill>
@@ -3028,6 +3040,9 @@
               </a:rPr>
               <a:t>Every group chat says </a:t>
             </a:r>
+            <a:pPr indent="0" marL="0">
+              <a:buNone/>
+            </a:pPr>
             <a:r>
               <a:rPr lang="en-US" sz="3400" dirty="0">
                 <a:solidFill>
@@ -3039,6 +3054,9 @@
               </a:rPr>
               <a:t>"bet?"</a:t>
             </a:r>
+            <a:pPr indent="0" marL="0">
+              <a:buNone/>
+            </a:pPr>
             <a:r>
               <a:rPr lang="en-US" sz="3400" dirty="0">
                 <a:solidFill>
@@ -3109,7 +3127,7 @@
                 <a:ea typeface="Raleway" pitchFamily="34" charset="-122"/>
                 <a:cs typeface="Raleway" pitchFamily="34" charset="-120"/>
               </a:rPr>
-              <a:t>"Man U will lose on Saturday."</a:t>
+              <a:t>"Your fave is getting evicted this Sunday."</a:t>
             </a:r>
             <a:endParaRPr lang="en-US" sz="1800" dirty="0"/>
           </a:p>
@@ -3170,7 +3188,7 @@
                 <a:ea typeface="Raleway" pitchFamily="34" charset="-122"/>
                 <a:cs typeface="Raleway" pitchFamily="34" charset="-120"/>
               </a:rPr>
-              <a:t>"BTC hits 150k by December."</a:t>
+              <a:t>"That album does 100M streams in week one."</a:t>
             </a:r>
             <a:endParaRPr lang="en-US" sz="1800" dirty="0"/>
           </a:p>
@@ -3231,7 +3249,7 @@
                 <a:ea typeface="Raleway" pitchFamily="34" charset="-122"/>
                 <a:cs typeface="Raleway" pitchFamily="34" charset="-120"/>
               </a:rPr>
-              <a:t>"Obi joins ADC before 2027."</a:t>
+              <a:t>"Super Eagles will lose on Saturday."</a:t>
             </a:r>
             <a:endParaRPr lang="en-US" sz="1800" dirty="0"/>
           </a:p>
@@ -3246,7 +3264,7 @@
         <p:spPr>
           <a:xfrm>
             <a:off x="548640" y="5120640"/>
-            <a:ext cx="5303520" cy="731520"/>
+            <a:ext cx="5303520" cy="822960"/>
           </a:xfrm>
           <a:prstGeom prst="rect">
             <a:avLst/>
@@ -3270,7 +3288,7 @@
                 <a:ea typeface="Raleway" pitchFamily="34" charset="-122"/>
                 <a:cs typeface="Raleway" pitchFamily="34" charset="-120"/>
               </a:rPr>
-              <a:t>Nobody writes it down. Nobody agrees what counts. Nobody holds the money.</a:t>
+              <a:t>BBNaija, elections, celebrity news, movies, music, football: nobody writes it down, agrees what counts, or holds the money.</a:t>
             </a:r>
             <a:endParaRPr lang="en-US" sz="1500" dirty="0"/>
           </a:p>
@@ -3512,6 +3530,9 @@
               </a:rPr>
               <a:t>POT</a:t>
             </a:r>
+            <a:pPr indent="0" marL="0">
+              <a:buNone/>
+            </a:pPr>
             <a:r>
               <a:rPr lang="en-US" sz="1100" dirty="0">
                 <a:solidFill>
@@ -3640,6 +3661,9 @@
               </a:rPr>
               <a:t>Four taps from argument to </a:t>
             </a:r>
+            <a:pPr indent="0" marL="0">
+              <a:buNone/>
+            </a:pPr>
             <a:r>
               <a:rPr lang="en-US" sz="3400" dirty="0">
                 <a:solidFill>
@@ -4503,6 +4527,9 @@
               </a:rPr>
               <a:t>POT</a:t>
             </a:r>
+            <a:pPr indent="0" marL="0">
+              <a:buNone/>
+            </a:pPr>
             <a:r>
               <a:rPr lang="en-US" sz="1100" dirty="0">
                 <a:solidFill>
@@ -4631,6 +4658,9 @@
               </a:rPr>
               <a:t>The AI writes a </a:t>
             </a:r>
+            <a:pPr indent="0" marL="0">
+              <a:buNone/>
+            </a:pPr>
             <a:r>
               <a:rPr lang="en-US" sz="3000" dirty="0">
                 <a:solidFill>
@@ -4642,6 +4672,9 @@
               </a:rPr>
               <a:t>fair</a:t>
             </a:r>
+            <a:pPr indent="0" marL="0">
+              <a:buNone/>
+            </a:pPr>
             <a:r>
               <a:rPr lang="en-US" sz="3000" dirty="0">
                 <a:solidFill>
@@ -5187,6 +5220,9 @@
               </a:rPr>
               <a:t>POT</a:t>
             </a:r>
+            <a:pPr indent="0" marL="0">
+              <a:buNone/>
+            </a:pPr>
             <a:r>
               <a:rPr lang="en-US" sz="1100" dirty="0">
                 <a:solidFill>
@@ -5315,6 +5351,9 @@
               </a:rPr>
               <a:t>Buy from the chat, the website, or </a:t>
             </a:r>
+            <a:pPr indent="0" marL="0">
+              <a:buNone/>
+            </a:pPr>
             <a:r>
               <a:rPr lang="en-US" sz="3000" dirty="0">
                 <a:solidFill>
@@ -5365,6 +5404,9 @@
               </a:rPr>
               <a:t>Phantom on the web page. </a:t>
             </a:r>
+            <a:pPr indent="0" marL="0">
+              <a:buNone/>
+            </a:pPr>
             <a:r>
               <a:rPr lang="en-US" sz="1500" dirty="0">
                 <a:solidFill>
@@ -5410,6 +5452,9 @@
               </a:rPr>
               <a:t>A Blink on X. </a:t>
             </a:r>
+            <a:pPr indent="0" marL="0">
+              <a:buNone/>
+            </a:pPr>
             <a:r>
               <a:rPr lang="en-US" sz="1500" dirty="0">
                 <a:solidFill>
@@ -5455,6 +5500,9 @@
               </a:rPr>
               <a:t>Credit for bringing people. </a:t>
             </a:r>
+            <a:pPr indent="0" marL="0">
+              <a:buNone/>
+            </a:pPr>
             <a:r>
               <a:rPr lang="en-US" sz="1500" dirty="0">
                 <a:solidFill>
@@ -5674,6 +5722,9 @@
               </a:rPr>
               <a:t>POT</a:t>
             </a:r>
+            <a:pPr indent="0" marL="0">
+              <a:buNone/>
+            </a:pPr>
             <a:r>
               <a:rPr lang="en-US" sz="1100" dirty="0">
                 <a:solidFill>
@@ -5970,6 +6021,9 @@
               </a:rPr>
               <a:t>The receipt is </a:t>
             </a:r>
+            <a:pPr indent="0" marL="0">
+              <a:buNone/>
+            </a:pPr>
             <a:r>
               <a:rPr lang="en-US" sz="3400" dirty="0">
                 <a:solidFill>
@@ -6388,6 +6442,9 @@
               </a:rPr>
               <a:t>POT</a:t>
             </a:r>
+            <a:pPr indent="0" marL="0">
+              <a:buNone/>
+            </a:pPr>
             <a:r>
               <a:rPr lang="en-US" sz="1100" dirty="0">
                 <a:solidFill>
@@ -6506,7 +6563,7 @@
               <a:buNone/>
             </a:pPr>
             <a:r>
-              <a:rPr lang="en-US" sz="3400" dirty="0">
+              <a:rPr lang="en-US" sz="3000" dirty="0">
                 <a:solidFill>
                   <a:srgbClr val="FFFFFF"/>
                 </a:solidFill>
@@ -6514,10 +6571,13 @@
                 <a:ea typeface="Russo One" pitchFamily="34" charset="-122"/>
                 <a:cs typeface="Russo One" pitchFamily="34" charset="-120"/>
               </a:rPr>
-              <a:t>Built on Panta's API for the </a:t>
-            </a:r>
-            <a:r>
-              <a:rPr lang="en-US" sz="3400" dirty="0">
+              <a:t>Every Panta API feature, and </a:t>
+            </a:r>
+            <a:pPr indent="0" marL="0">
+              <a:buNone/>
+            </a:pPr>
+            <a:r>
+              <a:rPr lang="en-US" sz="3000" dirty="0">
                 <a:solidFill>
                   <a:srgbClr val="FFD101"/>
                 </a:solidFill>
@@ -6525,33 +6585,61 @@
                 <a:ea typeface="Russo One" pitchFamily="34" charset="-122"/>
                 <a:cs typeface="Russo One" pitchFamily="34" charset="-120"/>
               </a:rPr>
-              <a:t>whole life</a:t>
-            </a:r>
-            <a:r>
-              <a:rPr lang="en-US" sz="3400" dirty="0">
-                <a:solidFill>
-                  <a:srgbClr val="FFFFFF"/>
+              <a:t>where Pot uses it</a:t>
+            </a:r>
+            <a:endParaRPr lang="en-US" sz="3000" dirty="0"/>
+          </a:p>
+        </p:txBody>
+      </p:sp>
+      <p:sp>
+        <p:nvSpPr>
+          <p:cNvPr id="6" name="Text 4"/>
+          <p:cNvSpPr/>
+          <p:nvPr/>
+        </p:nvSpPr>
+        <p:spPr>
+          <a:xfrm>
+            <a:off x="548640" y="1920240"/>
+            <a:ext cx="2743200" cy="1554480"/>
+          </a:xfrm>
+          <a:prstGeom prst="rect">
+            <a:avLst/>
+          </a:prstGeom>
+          <a:noFill/>
+          <a:ln/>
+        </p:spPr>
+        <p:txBody>
+          <a:bodyPr wrap="square" lIns="0" tIns="0" rIns="0" bIns="0" rtlCol="0" anchor="t"/>
+          <a:lstStyle/>
+          <a:p>
+            <a:pPr indent="0" marL="0">
+              <a:buNone/>
+            </a:pPr>
+            <a:r>
+              <a:rPr lang="en-US" sz="11000" dirty="0">
+                <a:solidFill>
+                  <a:srgbClr val="FFD101"/>
                 </a:solidFill>
                 <a:latin typeface="Russo One" pitchFamily="34" charset="0"/>
                 <a:ea typeface="Russo One" pitchFamily="34" charset="-122"/>
                 <a:cs typeface="Russo One" pitchFamily="34" charset="-120"/>
               </a:rPr>
-              <a:t> of a market</a:t>
-            </a:r>
-            <a:endParaRPr lang="en-US" sz="3400" dirty="0"/>
-          </a:p>
-        </p:txBody>
-      </p:sp>
-      <p:sp>
-        <p:nvSpPr>
-          <p:cNvPr id="6" name="Text 4"/>
-          <p:cNvSpPr/>
-          <p:nvPr/>
-        </p:nvSpPr>
-        <p:spPr>
-          <a:xfrm>
-            <a:off x="548640" y="2011680"/>
-            <a:ext cx="2926080" cy="1737360"/>
+              <a:t>15</a:t>
+            </a:r>
+            <a:endParaRPr lang="en-US" sz="11000" dirty="0"/>
+          </a:p>
+        </p:txBody>
+      </p:sp>
+      <p:sp>
+        <p:nvSpPr>
+          <p:cNvPr id="7" name="Text 5"/>
+          <p:cNvSpPr/>
+          <p:nvPr/>
+        </p:nvSpPr>
+        <p:spPr>
+          <a:xfrm>
+            <a:off x="548640" y="3566160"/>
+            <a:ext cx="2834640" cy="914400"/>
           </a:xfrm>
           <a:prstGeom prst="rect">
             <a:avLst/>
@@ -6567,46 +6655,7 @@
               <a:buNone/>
             </a:pPr>
             <a:r>
-              <a:rPr lang="en-US" sz="12000" dirty="0">
-                <a:solidFill>
-                  <a:srgbClr val="FFD101"/>
-                </a:solidFill>
-                <a:latin typeface="Russo One" pitchFamily="34" charset="0"/>
-                <a:ea typeface="Russo One" pitchFamily="34" charset="-122"/>
-                <a:cs typeface="Russo One" pitchFamily="34" charset="-120"/>
-              </a:rPr>
-              <a:t>16</a:t>
-            </a:r>
-            <a:endParaRPr lang="en-US" sz="12000" dirty="0"/>
-          </a:p>
-        </p:txBody>
-      </p:sp>
-      <p:sp>
-        <p:nvSpPr>
-          <p:cNvPr id="7" name="Text 5"/>
-          <p:cNvSpPr/>
-          <p:nvPr/>
-        </p:nvSpPr>
-        <p:spPr>
-          <a:xfrm>
-            <a:off x="548640" y="3840480"/>
-            <a:ext cx="3017520" cy="1005840"/>
-          </a:xfrm>
-          <a:prstGeom prst="rect">
-            <a:avLst/>
-          </a:prstGeom>
-          <a:noFill/>
-          <a:ln/>
-        </p:spPr>
-        <p:txBody>
-          <a:bodyPr wrap="square" lIns="0" tIns="0" rIns="0" bIns="0" rtlCol="0" anchor="t"/>
-          <a:lstStyle/>
-          <a:p>
-            <a:pPr indent="0" marL="0">
-              <a:buNone/>
-            </a:pPr>
-            <a:r>
-              <a:rPr lang="en-US" sz="1500" dirty="0">
+              <a:rPr lang="en-US" sz="1400" dirty="0">
                 <a:solidFill>
                   <a:srgbClr val="F2F2F2"/>
                 </a:solidFill>
@@ -6614,9 +6663,9 @@
                 <a:ea typeface="Raleway" pitchFamily="34" charset="-122"/>
                 <a:cs typeface="Raleway" pitchFamily="34" charset="-120"/>
               </a:rPr>
-              <a:t>Panta endpoints used, from making a market to claiming the creator's cut</a:t>
-            </a:r>
-            <a:endParaRPr lang="en-US" sz="1500" dirty="0"/>
+              <a:t>Panta endpoints, from making a market to claiming the creator's cut</a:t>
+            </a:r>
+            <a:endParaRPr lang="en-US" sz="1400" dirty="0"/>
           </a:p>
         </p:txBody>
       </p:sp>
@@ -6628,8 +6677,8 @@
         </p:nvSpPr>
         <p:spPr>
           <a:xfrm>
-            <a:off x="548640" y="4983480"/>
-            <a:ext cx="3017520" cy="1097280"/>
+            <a:off x="548640" y="4572000"/>
+            <a:ext cx="2834640" cy="1463040"/>
           </a:xfrm>
           <a:prstGeom prst="rect">
             <a:avLst/>
@@ -6653,7 +6702,7 @@
                 <a:ea typeface="Raleway" pitchFamily="34" charset="-122"/>
                 <a:cs typeface="Raleway" pitchFamily="34" charset="-120"/>
               </a:rPr>
-              <a:t>Rate-limited and cached reads. Only allow-listed writes. A second lock blocks every live write until it's switched on.</a:t>
+              <a:t>Checked read-only against the live API (scripts/live-probe.mts). Full flow runs end to end in the sandbox (scripts/sandbox-e2e.ts). 177 automated tests.</a:t>
             </a:r>
             <a:endParaRPr lang="en-US" sz="1200" dirty="0"/>
           </a:p>
@@ -6661,7 +6710,7 @@
       </p:sp>
       <p:graphicFrame>
         <p:nvGraphicFramePr>
-          <p:cNvPr id="9" name="Table 0"/>
+          <p:cNvPr id="8" name="Table 0"/>
           <p:cNvGraphicFramePr>
             <a:graphicFrameLocks noGrp="1"/>
           </p:cNvGraphicFramePr>
@@ -6674,28 +6723,29 @@
           </p:nvPr>
         </p:nvGraphicFramePr>
         <p:xfrm>
-          <a:off x="4023360" y="2148840"/>
-          <a:ext cx="7616952" cy="914400"/>
+          <a:off x="3611880" y="1920240"/>
+          <a:ext cx="8028432" cy="914400"/>
         </p:xfrm>
         <a:graphic>
           <a:graphicData uri="http://schemas.openxmlformats.org/drawingml/2006/table">
             <a:tbl>
               <a:tblPr/>
               <a:tblGrid>
-                <a:gridCol w="1234440"/>
-                <a:gridCol w="6382512"/>
+                <a:gridCol w="1554480"/>
+                <a:gridCol w="3200400"/>
+                <a:gridCol w="3273552"/>
               </a:tblGrid>
-              <a:tr h="896112">
+              <a:tr h="548640">
                 <a:tc>
                   <a:txBody>
                     <a:bodyPr/>
                     <a:lstStyle/>
                     <a:p>
-                      <a:pPr algn="ctr" indent="0" marL="0">
+                      <a:pPr indent="0" marL="0">
                         <a:buNone/>
                       </a:pPr>
                       <a:r>
-                        <a:rPr lang="en-US" sz="1500" b="1" dirty="0">
+                        <a:rPr lang="en-US" sz="1200" b="1" dirty="0">
                           <a:solidFill>
                             <a:srgbClr val="262626"/>
                           </a:solidFill>
@@ -6703,16 +6753,16 @@
                           <a:ea typeface="Russo One" pitchFamily="34" charset="-122"/>
                           <a:cs typeface="Russo One" pitchFamily="34" charset="-120"/>
                         </a:rPr>
-                        <a:t>Read</a:t>
+                        <a:t>Panta feature</a:t>
                       </a:r>
-                      <a:endParaRPr lang="en-US" sz="1500" dirty="0">
+                      <a:endParaRPr lang="en-US" sz="1200" dirty="0">
                         <a:latin typeface="Russo One" charset="0"/>
                         <a:ea typeface="Russo One" charset="0"/>
                         <a:cs typeface="Russo One" charset="0"/>
                       </a:endParaRPr>
                     </a:p>
                   </a:txBody>
-                  <a:tcPr marL="109728" marR="109728" marT="109728" marB="109728" anchor="ctr">
+                  <a:tcPr marL="73152" marR="73152" marT="73152" marB="73152" anchor="ctr">
                     <a:lnL w="12700" cap="flat" cmpd="sng" algn="ctr">
                       <a:solidFill>
                         <a:srgbClr val="4A4A4A"/>
@@ -6763,77 +6813,7 @@
                         <a:buNone/>
                       </a:pPr>
                       <a:r>
-                        <a:rPr lang="en-US" sz="1300" dirty="0">
-                          <a:solidFill>
-                            <a:srgbClr val="F2F2F2"/>
-                          </a:solidFill>
-                          <a:latin typeface="Raleway" pitchFamily="34" charset="0"/>
-                          <a:ea typeface="Raleway" pitchFamily="34" charset="-122"/>
-                          <a:cs typeface="Raleway" pitchFamily="34" charset="-120"/>
-                        </a:rPr>
-                        <a:t>GET /markets/ · /markets/{id}/ · /markets/{id}/trades/ · /positions/ · /wallets/{w}/trades/ · /trades/{sig}/</a:t>
-                      </a:r>
-                      <a:endParaRPr lang="en-US" sz="1300" dirty="0">
-                        <a:latin typeface="Raleway" charset="0"/>
-                        <a:ea typeface="Raleway" charset="0"/>
-                        <a:cs typeface="Raleway" charset="0"/>
-                      </a:endParaRPr>
-                    </a:p>
-                  </a:txBody>
-                  <a:tcPr marL="109728" marR="109728" marT="109728" marB="109728" anchor="ctr">
-                    <a:lnL w="12700" cap="flat" cmpd="sng" algn="ctr">
-                      <a:solidFill>
-                        <a:srgbClr val="4A4A4A"/>
-                      </a:solidFill>
-                      <a:prstDash val="solid"/>
-                      <a:round/>
-                      <a:headEnd type="none" w="med" len="med"/>
-                      <a:tailEnd type="none" w="med" len="med"/>
-                    </a:lnL>
-                    <a:lnR w="12700" cap="flat" cmpd="sng" algn="ctr">
-                      <a:solidFill>
-                        <a:srgbClr val="4A4A4A"/>
-                      </a:solidFill>
-                      <a:prstDash val="solid"/>
-                      <a:round/>
-                      <a:headEnd type="none" w="med" len="med"/>
-                      <a:tailEnd type="none" w="med" len="med"/>
-                    </a:lnR>
-                    <a:lnT w="12700" cap="flat" cmpd="sng" algn="ctr">
-                      <a:solidFill>
-                        <a:srgbClr val="4A4A4A"/>
-                      </a:solidFill>
-                      <a:prstDash val="solid"/>
-                      <a:round/>
-                      <a:headEnd type="none" w="med" len="med"/>
-                      <a:tailEnd type="none" w="med" len="med"/>
-                    </a:lnT>
-                    <a:lnB w="12700" cap="flat" cmpd="sng" algn="ctr">
-                      <a:solidFill>
-                        <a:srgbClr val="4A4A4A"/>
-                      </a:solidFill>
-                      <a:prstDash val="solid"/>
-                      <a:round/>
-                      <a:headEnd type="none" w="med" len="med"/>
-                      <a:tailEnd type="none" w="med" len="med"/>
-                    </a:lnB>
-                    <a:solidFill>
-                      <a:srgbClr val="333333"/>
-                    </a:solidFill>
-                  </a:tcPr>
-                </a:tc>
-              </a:tr>
-              <a:tr h="896112">
-                <a:tc>
-                  <a:txBody>
-                    <a:bodyPr/>
-                    <a:lstStyle/>
-                    <a:p>
-                      <a:pPr algn="ctr" indent="0" marL="0">
-                        <a:buNone/>
-                      </a:pPr>
-                      <a:r>
-                        <a:rPr lang="en-US" sz="1500" b="1" dirty="0">
+                        <a:rPr lang="en-US" sz="1200" b="1" dirty="0">
                           <a:solidFill>
                             <a:srgbClr val="262626"/>
                           </a:solidFill>
@@ -6841,16 +6821,16 @@
                           <a:ea typeface="Russo One" pitchFamily="34" charset="-122"/>
                           <a:cs typeface="Russo One" pitchFamily="34" charset="-120"/>
                         </a:rPr>
-                        <a:t>Buy</a:t>
+                        <a:t>Endpoints</a:t>
                       </a:r>
-                      <a:endParaRPr lang="en-US" sz="1500" dirty="0">
+                      <a:endParaRPr lang="en-US" sz="1200" dirty="0">
                         <a:latin typeface="Russo One" charset="0"/>
                         <a:ea typeface="Russo One" charset="0"/>
                         <a:cs typeface="Russo One" charset="0"/>
                       </a:endParaRPr>
                     </a:p>
                   </a:txBody>
-                  <a:tcPr marL="109728" marR="109728" marT="109728" marB="109728" anchor="ctr">
+                  <a:tcPr marL="73152" marR="73152" marT="73152" marB="73152" anchor="ctr">
                     <a:lnL w="12700" cap="flat" cmpd="sng" algn="ctr">
                       <a:solidFill>
                         <a:srgbClr val="4A4A4A"/>
@@ -6901,77 +6881,7 @@
                         <a:buNone/>
                       </a:pPr>
                       <a:r>
-                        <a:rPr lang="en-US" sz="1300" dirty="0">
-                          <a:solidFill>
-                            <a:srgbClr val="F2F2F2"/>
-                          </a:solidFill>
-                          <a:latin typeface="Raleway" pitchFamily="34" charset="0"/>
-                          <a:ea typeface="Raleway" pitchFamily="34" charset="-122"/>
-                          <a:cs typeface="Raleway" pitchFamily="34" charset="-120"/>
-                        </a:rPr>
-                        <a:t>primaryorderquote → primaryorderbuild → wallet signs → primaryordersubmit → primaryorderverify → /trades/ (credits the group's link)</a:t>
-                      </a:r>
-                      <a:endParaRPr lang="en-US" sz="1300" dirty="0">
-                        <a:latin typeface="Raleway" charset="0"/>
-                        <a:ea typeface="Raleway" charset="0"/>
-                        <a:cs typeface="Raleway" charset="0"/>
-                      </a:endParaRPr>
-                    </a:p>
-                  </a:txBody>
-                  <a:tcPr marL="109728" marR="109728" marT="109728" marB="109728" anchor="ctr">
-                    <a:lnL w="12700" cap="flat" cmpd="sng" algn="ctr">
-                      <a:solidFill>
-                        <a:srgbClr val="4A4A4A"/>
-                      </a:solidFill>
-                      <a:prstDash val="solid"/>
-                      <a:round/>
-                      <a:headEnd type="none" w="med" len="med"/>
-                      <a:tailEnd type="none" w="med" len="med"/>
-                    </a:lnL>
-                    <a:lnR w="12700" cap="flat" cmpd="sng" algn="ctr">
-                      <a:solidFill>
-                        <a:srgbClr val="4A4A4A"/>
-                      </a:solidFill>
-                      <a:prstDash val="solid"/>
-                      <a:round/>
-                      <a:headEnd type="none" w="med" len="med"/>
-                      <a:tailEnd type="none" w="med" len="med"/>
-                    </a:lnR>
-                    <a:lnT w="12700" cap="flat" cmpd="sng" algn="ctr">
-                      <a:solidFill>
-                        <a:srgbClr val="4A4A4A"/>
-                      </a:solidFill>
-                      <a:prstDash val="solid"/>
-                      <a:round/>
-                      <a:headEnd type="none" w="med" len="med"/>
-                      <a:tailEnd type="none" w="med" len="med"/>
-                    </a:lnT>
-                    <a:lnB w="12700" cap="flat" cmpd="sng" algn="ctr">
-                      <a:solidFill>
-                        <a:srgbClr val="4A4A4A"/>
-                      </a:solidFill>
-                      <a:prstDash val="solid"/>
-                      <a:round/>
-                      <a:headEnd type="none" w="med" len="med"/>
-                      <a:tailEnd type="none" w="med" len="med"/>
-                    </a:lnB>
-                    <a:solidFill>
-                      <a:srgbClr val="262626"/>
-                    </a:solidFill>
-                  </a:tcPr>
-                </a:tc>
-              </a:tr>
-              <a:tr h="896112">
-                <a:tc>
-                  <a:txBody>
-                    <a:bodyPr/>
-                    <a:lstStyle/>
-                    <a:p>
-                      <a:pPr algn="ctr" indent="0" marL="0">
-                        <a:buNone/>
-                      </a:pPr>
-                      <a:r>
-                        <a:rPr lang="en-US" sz="1500" b="1" dirty="0">
+                        <a:rPr lang="en-US" sz="1200" b="1" dirty="0">
                           <a:solidFill>
                             <a:srgbClr val="262626"/>
                           </a:solidFill>
@@ -6979,16 +6889,16 @@
                           <a:ea typeface="Russo One" pitchFamily="34" charset="-122"/>
                           <a:cs typeface="Russo One" pitchFamily="34" charset="-120"/>
                         </a:rPr>
-                        <a:t>Create</a:t>
+                        <a:t>Where Pot uses it</a:t>
                       </a:r>
-                      <a:endParaRPr lang="en-US" sz="1500" dirty="0">
+                      <a:endParaRPr lang="en-US" sz="1200" dirty="0">
                         <a:latin typeface="Russo One" charset="0"/>
                         <a:ea typeface="Russo One" charset="0"/>
                         <a:cs typeface="Russo One" charset="0"/>
                       </a:endParaRPr>
                     </a:p>
                   </a:txBody>
-                  <a:tcPr marL="109728" marR="109728" marT="109728" marB="109728" anchor="ctr">
+                  <a:tcPr marL="73152" marR="73152" marT="73152" marB="73152" anchor="ctr">
                     <a:lnL w="12700" cap="flat" cmpd="sng" algn="ctr">
                       <a:solidFill>
                         <a:srgbClr val="4A4A4A"/>
@@ -7027,6 +6937,76 @@
                     </a:lnB>
                     <a:solidFill>
                       <a:srgbClr val="FFD101"/>
+                    </a:solidFill>
+                  </a:tcPr>
+                </a:tc>
+              </a:tr>
+              <a:tr h="548640">
+                <a:tc>
+                  <a:txBody>
+                    <a:bodyPr/>
+                    <a:lstStyle/>
+                    <a:p>
+                      <a:pPr indent="0" marL="0">
+                        <a:buNone/>
+                      </a:pPr>
+                      <a:r>
+                        <a:rPr lang="en-US" sz="1100" b="1" dirty="0">
+                          <a:solidFill>
+                            <a:srgbClr val="FFFFFF"/>
+                          </a:solidFill>
+                          <a:latin typeface="Raleway" pitchFamily="34" charset="0"/>
+                          <a:ea typeface="Raleway" pitchFamily="34" charset="-122"/>
+                          <a:cs typeface="Raleway" pitchFamily="34" charset="-120"/>
+                        </a:rPr>
+                        <a:t>Market data</a:t>
+                      </a:r>
+                      <a:endParaRPr lang="en-US" sz="1100" dirty="0">
+                        <a:latin typeface="Raleway" charset="0"/>
+                        <a:ea typeface="Raleway" charset="0"/>
+                        <a:cs typeface="Raleway" charset="0"/>
+                      </a:endParaRPr>
+                    </a:p>
+                  </a:txBody>
+                  <a:tcPr marL="73152" marR="73152" marT="73152" marB="73152" anchor="ctr">
+                    <a:lnL w="12700" cap="flat" cmpd="sng" algn="ctr">
+                      <a:solidFill>
+                        <a:srgbClr val="4A4A4A"/>
+                      </a:solidFill>
+                      <a:prstDash val="solid"/>
+                      <a:round/>
+                      <a:headEnd type="none" w="med" len="med"/>
+                      <a:tailEnd type="none" w="med" len="med"/>
+                    </a:lnL>
+                    <a:lnR w="12700" cap="flat" cmpd="sng" algn="ctr">
+                      <a:solidFill>
+                        <a:srgbClr val="4A4A4A"/>
+                      </a:solidFill>
+                      <a:prstDash val="solid"/>
+                      <a:round/>
+                      <a:headEnd type="none" w="med" len="med"/>
+                      <a:tailEnd type="none" w="med" len="med"/>
+                    </a:lnR>
+                    <a:lnT w="12700" cap="flat" cmpd="sng" algn="ctr">
+                      <a:solidFill>
+                        <a:srgbClr val="4A4A4A"/>
+                      </a:solidFill>
+                      <a:prstDash val="solid"/>
+                      <a:round/>
+                      <a:headEnd type="none" w="med" len="med"/>
+                      <a:tailEnd type="none" w="med" len="med"/>
+                    </a:lnT>
+                    <a:lnB w="12700" cap="flat" cmpd="sng" algn="ctr">
+                      <a:solidFill>
+                        <a:srgbClr val="4A4A4A"/>
+                      </a:solidFill>
+                      <a:prstDash val="solid"/>
+                      <a:round/>
+                      <a:headEnd type="none" w="med" len="med"/>
+                      <a:tailEnd type="none" w="med" len="med"/>
+                    </a:lnB>
+                    <a:solidFill>
+                      <a:srgbClr val="262626"/>
                     </a:solidFill>
                   </a:tcPr>
                 </a:tc>
@@ -7039,7 +7019,7 @@
                         <a:buNone/>
                       </a:pPr>
                       <a:r>
-                        <a:rPr lang="en-US" sz="1300" dirty="0">
+                        <a:rPr lang="en-US" sz="1100" dirty="0">
                           <a:solidFill>
                             <a:srgbClr val="F2F2F2"/>
                           </a:solidFill>
@@ -7047,16 +7027,16 @@
                           <a:ea typeface="Raleway" pitchFamily="34" charset="-122"/>
                           <a:cs typeface="Raleway" pitchFamily="34" charset="-120"/>
                         </a:rPr>
-                        <a:t>markets/create/quote → markets/create/build → admin signs and pays → markets/register</a:t>
+                        <a:t>GET /markets/ · /markets/{id}/ · /markets/{id}/trades/</a:t>
                       </a:r>
-                      <a:endParaRPr lang="en-US" sz="1300" dirty="0">
+                      <a:endParaRPr lang="en-US" sz="1100" dirty="0">
                         <a:latin typeface="Raleway" charset="0"/>
                         <a:ea typeface="Raleway" charset="0"/>
                         <a:cs typeface="Raleway" charset="0"/>
                       </a:endParaRPr>
                     </a:p>
                   </a:txBody>
-                  <a:tcPr marL="109728" marR="109728" marT="109728" marB="109728" anchor="ctr">
+                  <a:tcPr marL="73152" marR="73152" marT="73152" marB="73152" anchor="ctr">
                     <a:lnL w="12700" cap="flat" cmpd="sng" algn="ctr">
                       <a:solidFill>
                         <a:srgbClr val="4A4A4A"/>
@@ -7094,77 +7074,7 @@
                       <a:tailEnd type="none" w="med" len="med"/>
                     </a:lnB>
                     <a:solidFill>
-                      <a:srgbClr val="333333"/>
-                    </a:solidFill>
-                  </a:tcPr>
-                </a:tc>
-              </a:tr>
-              <a:tr h="896112">
-                <a:tc>
-                  <a:txBody>
-                    <a:bodyPr/>
-                    <a:lstStyle/>
-                    <a:p>
-                      <a:pPr algn="ctr" indent="0" marL="0">
-                        <a:buNone/>
-                      </a:pPr>
-                      <a:r>
-                        <a:rPr lang="en-US" sz="1500" b="1" dirty="0">
-                          <a:solidFill>
-                            <a:srgbClr val="262626"/>
-                          </a:solidFill>
-                          <a:latin typeface="Russo One" pitchFamily="34" charset="0"/>
-                          <a:ea typeface="Russo One" pitchFamily="34" charset="-122"/>
-                          <a:cs typeface="Russo One" pitchFamily="34" charset="-120"/>
-                        </a:rPr>
-                        <a:t>Claim</a:t>
-                      </a:r>
-                      <a:endParaRPr lang="en-US" sz="1500" dirty="0">
-                        <a:latin typeface="Russo One" charset="0"/>
-                        <a:ea typeface="Russo One" charset="0"/>
-                        <a:cs typeface="Russo One" charset="0"/>
-                      </a:endParaRPr>
-                    </a:p>
-                  </a:txBody>
-                  <a:tcPr marL="109728" marR="109728" marT="109728" marB="109728" anchor="ctr">
-                    <a:lnL w="12700" cap="flat" cmpd="sng" algn="ctr">
-                      <a:solidFill>
-                        <a:srgbClr val="4A4A4A"/>
-                      </a:solidFill>
-                      <a:prstDash val="solid"/>
-                      <a:round/>
-                      <a:headEnd type="none" w="med" len="med"/>
-                      <a:tailEnd type="none" w="med" len="med"/>
-                    </a:lnL>
-                    <a:lnR w="12700" cap="flat" cmpd="sng" algn="ctr">
-                      <a:solidFill>
-                        <a:srgbClr val="4A4A4A"/>
-                      </a:solidFill>
-                      <a:prstDash val="solid"/>
-                      <a:round/>
-                      <a:headEnd type="none" w="med" len="med"/>
-                      <a:tailEnd type="none" w="med" len="med"/>
-                    </a:lnR>
-                    <a:lnT w="12700" cap="flat" cmpd="sng" algn="ctr">
-                      <a:solidFill>
-                        <a:srgbClr val="4A4A4A"/>
-                      </a:solidFill>
-                      <a:prstDash val="solid"/>
-                      <a:round/>
-                      <a:headEnd type="none" w="med" len="med"/>
-                      <a:tailEnd type="none" w="med" len="med"/>
-                    </a:lnT>
-                    <a:lnB w="12700" cap="flat" cmpd="sng" algn="ctr">
-                      <a:solidFill>
-                        <a:srgbClr val="4A4A4A"/>
-                      </a:solidFill>
-                      <a:prstDash val="solid"/>
-                      <a:round/>
-                      <a:headEnd type="none" w="med" len="med"/>
-                      <a:tailEnd type="none" w="med" len="med"/>
-                    </a:lnB>
-                    <a:solidFill>
-                      <a:srgbClr val="FFD101"/>
+                      <a:srgbClr val="262626"/>
                     </a:solidFill>
                   </a:tcPr>
                 </a:tc>
@@ -7177,7 +7087,7 @@
                         <a:buNone/>
                       </a:pPr>
                       <a:r>
-                        <a:rPr lang="en-US" sz="1300" dirty="0">
+                        <a:rPr lang="en-US" sz="1100" dirty="0">
                           <a:solidFill>
                             <a:srgbClr val="F2F2F2"/>
                           </a:solidFill>
@@ -7185,16 +7095,16 @@
                           <a:ea typeface="Raleway" pitchFamily="34" charset="-122"/>
                           <a:cs typeface="Raleway" pitchFamily="34" charset="-120"/>
                         </a:rPr>
-                        <a:t>claim/build (winnings) · claim/creator-fees/build (creator's cut) → /trades/ report</a:t>
+                        <a:t>Live cards in chat (/panta), home page, market page, receipts</a:t>
                       </a:r>
-                      <a:endParaRPr lang="en-US" sz="1300" dirty="0">
+                      <a:endParaRPr lang="en-US" sz="1100" dirty="0">
                         <a:latin typeface="Raleway" charset="0"/>
                         <a:ea typeface="Raleway" charset="0"/>
                         <a:cs typeface="Raleway" charset="0"/>
                       </a:endParaRPr>
                     </a:p>
                   </a:txBody>
-                  <a:tcPr marL="109728" marR="109728" marT="109728" marB="109728" anchor="ctr">
+                  <a:tcPr marL="73152" marR="73152" marT="73152" marB="73152" anchor="ctr">
                     <a:lnL w="12700" cap="flat" cmpd="sng" algn="ctr">
                       <a:solidFill>
                         <a:srgbClr val="4A4A4A"/>
@@ -7233,6 +7143,1036 @@
                     </a:lnB>
                     <a:solidFill>
                       <a:srgbClr val="262626"/>
+                    </a:solidFill>
+                  </a:tcPr>
+                </a:tc>
+              </a:tr>
+              <a:tr h="548640">
+                <a:tc>
+                  <a:txBody>
+                    <a:bodyPr/>
+                    <a:lstStyle/>
+                    <a:p>
+                      <a:pPr indent="0" marL="0">
+                        <a:buNone/>
+                      </a:pPr>
+                      <a:r>
+                        <a:rPr lang="en-US" sz="1100" b="1" dirty="0">
+                          <a:solidFill>
+                            <a:srgbClr val="FFFFFF"/>
+                          </a:solidFill>
+                          <a:latin typeface="Raleway" pitchFamily="34" charset="0"/>
+                          <a:ea typeface="Raleway" pitchFamily="34" charset="-122"/>
+                          <a:cs typeface="Raleway" pitchFamily="34" charset="-120"/>
+                        </a:rPr>
+                        <a:t>Positions</a:t>
+                      </a:r>
+                      <a:endParaRPr lang="en-US" sz="1100" dirty="0">
+                        <a:latin typeface="Raleway" charset="0"/>
+                        <a:ea typeface="Raleway" charset="0"/>
+                        <a:cs typeface="Raleway" charset="0"/>
+                      </a:endParaRPr>
+                    </a:p>
+                  </a:txBody>
+                  <a:tcPr marL="73152" marR="73152" marT="73152" marB="73152" anchor="ctr">
+                    <a:lnL w="12700" cap="flat" cmpd="sng" algn="ctr">
+                      <a:solidFill>
+                        <a:srgbClr val="4A4A4A"/>
+                      </a:solidFill>
+                      <a:prstDash val="solid"/>
+                      <a:round/>
+                      <a:headEnd type="none" w="med" len="med"/>
+                      <a:tailEnd type="none" w="med" len="med"/>
+                    </a:lnL>
+                    <a:lnR w="12700" cap="flat" cmpd="sng" algn="ctr">
+                      <a:solidFill>
+                        <a:srgbClr val="4A4A4A"/>
+                      </a:solidFill>
+                      <a:prstDash val="solid"/>
+                      <a:round/>
+                      <a:headEnd type="none" w="med" len="med"/>
+                      <a:tailEnd type="none" w="med" len="med"/>
+                    </a:lnR>
+                    <a:lnT w="12700" cap="flat" cmpd="sng" algn="ctr">
+                      <a:solidFill>
+                        <a:srgbClr val="4A4A4A"/>
+                      </a:solidFill>
+                      <a:prstDash val="solid"/>
+                      <a:round/>
+                      <a:headEnd type="none" w="med" len="med"/>
+                      <a:tailEnd type="none" w="med" len="med"/>
+                    </a:lnT>
+                    <a:lnB w="12700" cap="flat" cmpd="sng" algn="ctr">
+                      <a:solidFill>
+                        <a:srgbClr val="4A4A4A"/>
+                      </a:solidFill>
+                      <a:prstDash val="solid"/>
+                      <a:round/>
+                      <a:headEnd type="none" w="med" len="med"/>
+                      <a:tailEnd type="none" w="med" len="med"/>
+                    </a:lnB>
+                    <a:solidFill>
+                      <a:srgbClr val="333333"/>
+                    </a:solidFill>
+                  </a:tcPr>
+                </a:tc>
+                <a:tc>
+                  <a:txBody>
+                    <a:bodyPr/>
+                    <a:lstStyle/>
+                    <a:p>
+                      <a:pPr indent="0" marL="0">
+                        <a:buNone/>
+                      </a:pPr>
+                      <a:r>
+                        <a:rPr lang="en-US" sz="1100" dirty="0">
+                          <a:solidFill>
+                            <a:srgbClr val="F2F2F2"/>
+                          </a:solidFill>
+                          <a:latin typeface="Raleway" pitchFamily="34" charset="0"/>
+                          <a:ea typeface="Raleway" pitchFamily="34" charset="-122"/>
+                          <a:cs typeface="Raleway" pitchFamily="34" charset="-120"/>
+                        </a:rPr>
+                        <a:t>GET /positions/ · /wallets/{w}/trades/</a:t>
+                      </a:r>
+                      <a:endParaRPr lang="en-US" sz="1100" dirty="0">
+                        <a:latin typeface="Raleway" charset="0"/>
+                        <a:ea typeface="Raleway" charset="0"/>
+                        <a:cs typeface="Raleway" charset="0"/>
+                      </a:endParaRPr>
+                    </a:p>
+                  </a:txBody>
+                  <a:tcPr marL="73152" marR="73152" marT="73152" marB="73152" anchor="ctr">
+                    <a:lnL w="12700" cap="flat" cmpd="sng" algn="ctr">
+                      <a:solidFill>
+                        <a:srgbClr val="4A4A4A"/>
+                      </a:solidFill>
+                      <a:prstDash val="solid"/>
+                      <a:round/>
+                      <a:headEnd type="none" w="med" len="med"/>
+                      <a:tailEnd type="none" w="med" len="med"/>
+                    </a:lnL>
+                    <a:lnR w="12700" cap="flat" cmpd="sng" algn="ctr">
+                      <a:solidFill>
+                        <a:srgbClr val="4A4A4A"/>
+                      </a:solidFill>
+                      <a:prstDash val="solid"/>
+                      <a:round/>
+                      <a:headEnd type="none" w="med" len="med"/>
+                      <a:tailEnd type="none" w="med" len="med"/>
+                    </a:lnR>
+                    <a:lnT w="12700" cap="flat" cmpd="sng" algn="ctr">
+                      <a:solidFill>
+                        <a:srgbClr val="4A4A4A"/>
+                      </a:solidFill>
+                      <a:prstDash val="solid"/>
+                      <a:round/>
+                      <a:headEnd type="none" w="med" len="med"/>
+                      <a:tailEnd type="none" w="med" len="med"/>
+                    </a:lnT>
+                    <a:lnB w="12700" cap="flat" cmpd="sng" algn="ctr">
+                      <a:solidFill>
+                        <a:srgbClr val="4A4A4A"/>
+                      </a:solidFill>
+                      <a:prstDash val="solid"/>
+                      <a:round/>
+                      <a:headEnd type="none" w="med" len="med"/>
+                      <a:tailEnd type="none" w="med" len="med"/>
+                    </a:lnB>
+                    <a:solidFill>
+                      <a:srgbClr val="333333"/>
+                    </a:solidFill>
+                  </a:tcPr>
+                </a:tc>
+                <a:tc>
+                  <a:txBody>
+                    <a:bodyPr/>
+                    <a:lstStyle/>
+                    <a:p>
+                      <a:pPr indent="0" marL="0">
+                        <a:buNone/>
+                      </a:pPr>
+                      <a:r>
+                        <a:rPr lang="en-US" sz="1100" dirty="0">
+                          <a:solidFill>
+                            <a:srgbClr val="F2F2F2"/>
+                          </a:solidFill>
+                          <a:latin typeface="Raleway" pitchFamily="34" charset="0"/>
+                          <a:ea typeface="Raleway" pitchFamily="34" charset="-122"/>
+                          <a:cs typeface="Raleway" pitchFamily="34" charset="-120"/>
+                        </a:rPr>
+                        <a:t>/mine, claim links, "first-ever Panta trade"</a:t>
+                      </a:r>
+                      <a:endParaRPr lang="en-US" sz="1100" dirty="0">
+                        <a:latin typeface="Raleway" charset="0"/>
+                        <a:ea typeface="Raleway" charset="0"/>
+                        <a:cs typeface="Raleway" charset="0"/>
+                      </a:endParaRPr>
+                    </a:p>
+                  </a:txBody>
+                  <a:tcPr marL="73152" marR="73152" marT="73152" marB="73152" anchor="ctr">
+                    <a:lnL w="12700" cap="flat" cmpd="sng" algn="ctr">
+                      <a:solidFill>
+                        <a:srgbClr val="4A4A4A"/>
+                      </a:solidFill>
+                      <a:prstDash val="solid"/>
+                      <a:round/>
+                      <a:headEnd type="none" w="med" len="med"/>
+                      <a:tailEnd type="none" w="med" len="med"/>
+                    </a:lnL>
+                    <a:lnR w="12700" cap="flat" cmpd="sng" algn="ctr">
+                      <a:solidFill>
+                        <a:srgbClr val="4A4A4A"/>
+                      </a:solidFill>
+                      <a:prstDash val="solid"/>
+                      <a:round/>
+                      <a:headEnd type="none" w="med" len="med"/>
+                      <a:tailEnd type="none" w="med" len="med"/>
+                    </a:lnR>
+                    <a:lnT w="12700" cap="flat" cmpd="sng" algn="ctr">
+                      <a:solidFill>
+                        <a:srgbClr val="4A4A4A"/>
+                      </a:solidFill>
+                      <a:prstDash val="solid"/>
+                      <a:round/>
+                      <a:headEnd type="none" w="med" len="med"/>
+                      <a:tailEnd type="none" w="med" len="med"/>
+                    </a:lnT>
+                    <a:lnB w="12700" cap="flat" cmpd="sng" algn="ctr">
+                      <a:solidFill>
+                        <a:srgbClr val="4A4A4A"/>
+                      </a:solidFill>
+                      <a:prstDash val="solid"/>
+                      <a:round/>
+                      <a:headEnd type="none" w="med" len="med"/>
+                      <a:tailEnd type="none" w="med" len="med"/>
+                    </a:lnB>
+                    <a:solidFill>
+                      <a:srgbClr val="333333"/>
+                    </a:solidFill>
+                  </a:tcPr>
+                </a:tc>
+              </a:tr>
+              <a:tr h="548640">
+                <a:tc>
+                  <a:txBody>
+                    <a:bodyPr/>
+                    <a:lstStyle/>
+                    <a:p>
+                      <a:pPr indent="0" marL="0">
+                        <a:buNone/>
+                      </a:pPr>
+                      <a:r>
+                        <a:rPr lang="en-US" sz="1100" b="1" dirty="0">
+                          <a:solidFill>
+                            <a:srgbClr val="FFFFFF"/>
+                          </a:solidFill>
+                          <a:latin typeface="Raleway" pitchFamily="34" charset="0"/>
+                          <a:ea typeface="Raleway" pitchFamily="34" charset="-122"/>
+                          <a:cs typeface="Raleway" pitchFamily="34" charset="-120"/>
+                        </a:rPr>
+                        <a:t>Primary buys</a:t>
+                      </a:r>
+                      <a:endParaRPr lang="en-US" sz="1100" dirty="0">
+                        <a:latin typeface="Raleway" charset="0"/>
+                        <a:ea typeface="Raleway" charset="0"/>
+                        <a:cs typeface="Raleway" charset="0"/>
+                      </a:endParaRPr>
+                    </a:p>
+                  </a:txBody>
+                  <a:tcPr marL="73152" marR="73152" marT="73152" marB="73152" anchor="ctr">
+                    <a:lnL w="12700" cap="flat" cmpd="sng" algn="ctr">
+                      <a:solidFill>
+                        <a:srgbClr val="4A4A4A"/>
+                      </a:solidFill>
+                      <a:prstDash val="solid"/>
+                      <a:round/>
+                      <a:headEnd type="none" w="med" len="med"/>
+                      <a:tailEnd type="none" w="med" len="med"/>
+                    </a:lnL>
+                    <a:lnR w="12700" cap="flat" cmpd="sng" algn="ctr">
+                      <a:solidFill>
+                        <a:srgbClr val="4A4A4A"/>
+                      </a:solidFill>
+                      <a:prstDash val="solid"/>
+                      <a:round/>
+                      <a:headEnd type="none" w="med" len="med"/>
+                      <a:tailEnd type="none" w="med" len="med"/>
+                    </a:lnR>
+                    <a:lnT w="12700" cap="flat" cmpd="sng" algn="ctr">
+                      <a:solidFill>
+                        <a:srgbClr val="4A4A4A"/>
+                      </a:solidFill>
+                      <a:prstDash val="solid"/>
+                      <a:round/>
+                      <a:headEnd type="none" w="med" len="med"/>
+                      <a:tailEnd type="none" w="med" len="med"/>
+                    </a:lnT>
+                    <a:lnB w="12700" cap="flat" cmpd="sng" algn="ctr">
+                      <a:solidFill>
+                        <a:srgbClr val="4A4A4A"/>
+                      </a:solidFill>
+                      <a:prstDash val="solid"/>
+                      <a:round/>
+                      <a:headEnd type="none" w="med" len="med"/>
+                      <a:tailEnd type="none" w="med" len="med"/>
+                    </a:lnB>
+                    <a:solidFill>
+                      <a:srgbClr val="262626"/>
+                    </a:solidFill>
+                  </a:tcPr>
+                </a:tc>
+                <a:tc>
+                  <a:txBody>
+                    <a:bodyPr/>
+                    <a:lstStyle/>
+                    <a:p>
+                      <a:pPr indent="0" marL="0">
+                        <a:buNone/>
+                      </a:pPr>
+                      <a:r>
+                        <a:rPr lang="en-US" sz="1100" dirty="0">
+                          <a:solidFill>
+                            <a:srgbClr val="F2F2F2"/>
+                          </a:solidFill>
+                          <a:latin typeface="Raleway" pitchFamily="34" charset="0"/>
+                          <a:ea typeface="Raleway" pitchFamily="34" charset="-122"/>
+                          <a:cs typeface="Raleway" pitchFamily="34" charset="-120"/>
+                        </a:rPr>
+                        <a:t>primaryorderquote → build → submit → verify</a:t>
+                      </a:r>
+                      <a:endParaRPr lang="en-US" sz="1100" dirty="0">
+                        <a:latin typeface="Raleway" charset="0"/>
+                        <a:ea typeface="Raleway" charset="0"/>
+                        <a:cs typeface="Raleway" charset="0"/>
+                      </a:endParaRPr>
+                    </a:p>
+                  </a:txBody>
+                  <a:tcPr marL="73152" marR="73152" marT="73152" marB="73152" anchor="ctr">
+                    <a:lnL w="12700" cap="flat" cmpd="sng" algn="ctr">
+                      <a:solidFill>
+                        <a:srgbClr val="4A4A4A"/>
+                      </a:solidFill>
+                      <a:prstDash val="solid"/>
+                      <a:round/>
+                      <a:headEnd type="none" w="med" len="med"/>
+                      <a:tailEnd type="none" w="med" len="med"/>
+                    </a:lnL>
+                    <a:lnR w="12700" cap="flat" cmpd="sng" algn="ctr">
+                      <a:solidFill>
+                        <a:srgbClr val="4A4A4A"/>
+                      </a:solidFill>
+                      <a:prstDash val="solid"/>
+                      <a:round/>
+                      <a:headEnd type="none" w="med" len="med"/>
+                      <a:tailEnd type="none" w="med" len="med"/>
+                    </a:lnR>
+                    <a:lnT w="12700" cap="flat" cmpd="sng" algn="ctr">
+                      <a:solidFill>
+                        <a:srgbClr val="4A4A4A"/>
+                      </a:solidFill>
+                      <a:prstDash val="solid"/>
+                      <a:round/>
+                      <a:headEnd type="none" w="med" len="med"/>
+                      <a:tailEnd type="none" w="med" len="med"/>
+                    </a:lnT>
+                    <a:lnB w="12700" cap="flat" cmpd="sng" algn="ctr">
+                      <a:solidFill>
+                        <a:srgbClr val="4A4A4A"/>
+                      </a:solidFill>
+                      <a:prstDash val="solid"/>
+                      <a:round/>
+                      <a:headEnd type="none" w="med" len="med"/>
+                      <a:tailEnd type="none" w="med" len="med"/>
+                    </a:lnB>
+                    <a:solidFill>
+                      <a:srgbClr val="262626"/>
+                    </a:solidFill>
+                  </a:tcPr>
+                </a:tc>
+                <a:tc>
+                  <a:txBody>
+                    <a:bodyPr/>
+                    <a:lstStyle/>
+                    <a:p>
+                      <a:pPr indent="0" marL="0">
+                        <a:buNone/>
+                      </a:pPr>
+                      <a:r>
+                        <a:rPr lang="en-US" sz="1100" dirty="0">
+                          <a:solidFill>
+                            <a:srgbClr val="F2F2F2"/>
+                          </a:solidFill>
+                          <a:latin typeface="Raleway" pitchFamily="34" charset="0"/>
+                          <a:ea typeface="Raleway" pitchFamily="34" charset="-122"/>
+                          <a:cs typeface="Raleway" pitchFamily="34" charset="-120"/>
+                        </a:rPr>
+                        <a:t>Buy YES/NO on the web page and in Blinks on X</a:t>
+                      </a:r>
+                      <a:endParaRPr lang="en-US" sz="1100" dirty="0">
+                        <a:latin typeface="Raleway" charset="0"/>
+                        <a:ea typeface="Raleway" charset="0"/>
+                        <a:cs typeface="Raleway" charset="0"/>
+                      </a:endParaRPr>
+                    </a:p>
+                  </a:txBody>
+                  <a:tcPr marL="73152" marR="73152" marT="73152" marB="73152" anchor="ctr">
+                    <a:lnL w="12700" cap="flat" cmpd="sng" algn="ctr">
+                      <a:solidFill>
+                        <a:srgbClr val="4A4A4A"/>
+                      </a:solidFill>
+                      <a:prstDash val="solid"/>
+                      <a:round/>
+                      <a:headEnd type="none" w="med" len="med"/>
+                      <a:tailEnd type="none" w="med" len="med"/>
+                    </a:lnL>
+                    <a:lnR w="12700" cap="flat" cmpd="sng" algn="ctr">
+                      <a:solidFill>
+                        <a:srgbClr val="4A4A4A"/>
+                      </a:solidFill>
+                      <a:prstDash val="solid"/>
+                      <a:round/>
+                      <a:headEnd type="none" w="med" len="med"/>
+                      <a:tailEnd type="none" w="med" len="med"/>
+                    </a:lnR>
+                    <a:lnT w="12700" cap="flat" cmpd="sng" algn="ctr">
+                      <a:solidFill>
+                        <a:srgbClr val="4A4A4A"/>
+                      </a:solidFill>
+                      <a:prstDash val="solid"/>
+                      <a:round/>
+                      <a:headEnd type="none" w="med" len="med"/>
+                      <a:tailEnd type="none" w="med" len="med"/>
+                    </a:lnT>
+                    <a:lnB w="12700" cap="flat" cmpd="sng" algn="ctr">
+                      <a:solidFill>
+                        <a:srgbClr val="4A4A4A"/>
+                      </a:solidFill>
+                      <a:prstDash val="solid"/>
+                      <a:round/>
+                      <a:headEnd type="none" w="med" len="med"/>
+                      <a:tailEnd type="none" w="med" len="med"/>
+                    </a:lnB>
+                    <a:solidFill>
+                      <a:srgbClr val="262626"/>
+                    </a:solidFill>
+                  </a:tcPr>
+                </a:tc>
+              </a:tr>
+              <a:tr h="548640">
+                <a:tc>
+                  <a:txBody>
+                    <a:bodyPr/>
+                    <a:lstStyle/>
+                    <a:p>
+                      <a:pPr indent="0" marL="0">
+                        <a:buNone/>
+                      </a:pPr>
+                      <a:r>
+                        <a:rPr lang="en-US" sz="1100" b="1" dirty="0">
+                          <a:solidFill>
+                            <a:srgbClr val="FFFFFF"/>
+                          </a:solidFill>
+                          <a:latin typeface="Raleway" pitchFamily="34" charset="0"/>
+                          <a:ea typeface="Raleway" pitchFamily="34" charset="-122"/>
+                          <a:cs typeface="Raleway" pitchFamily="34" charset="-120"/>
+                        </a:rPr>
+                        <a:t>Attribution</a:t>
+                      </a:r>
+                      <a:endParaRPr lang="en-US" sz="1100" dirty="0">
+                        <a:latin typeface="Raleway" charset="0"/>
+                        <a:ea typeface="Raleway" charset="0"/>
+                        <a:cs typeface="Raleway" charset="0"/>
+                      </a:endParaRPr>
+                    </a:p>
+                  </a:txBody>
+                  <a:tcPr marL="73152" marR="73152" marT="73152" marB="73152" anchor="ctr">
+                    <a:lnL w="12700" cap="flat" cmpd="sng" algn="ctr">
+                      <a:solidFill>
+                        <a:srgbClr val="4A4A4A"/>
+                      </a:solidFill>
+                      <a:prstDash val="solid"/>
+                      <a:round/>
+                      <a:headEnd type="none" w="med" len="med"/>
+                      <a:tailEnd type="none" w="med" len="med"/>
+                    </a:lnL>
+                    <a:lnR w="12700" cap="flat" cmpd="sng" algn="ctr">
+                      <a:solidFill>
+                        <a:srgbClr val="4A4A4A"/>
+                      </a:solidFill>
+                      <a:prstDash val="solid"/>
+                      <a:round/>
+                      <a:headEnd type="none" w="med" len="med"/>
+                      <a:tailEnd type="none" w="med" len="med"/>
+                    </a:lnR>
+                    <a:lnT w="12700" cap="flat" cmpd="sng" algn="ctr">
+                      <a:solidFill>
+                        <a:srgbClr val="4A4A4A"/>
+                      </a:solidFill>
+                      <a:prstDash val="solid"/>
+                      <a:round/>
+                      <a:headEnd type="none" w="med" len="med"/>
+                      <a:tailEnd type="none" w="med" len="med"/>
+                    </a:lnT>
+                    <a:lnB w="12700" cap="flat" cmpd="sng" algn="ctr">
+                      <a:solidFill>
+                        <a:srgbClr val="4A4A4A"/>
+                      </a:solidFill>
+                      <a:prstDash val="solid"/>
+                      <a:round/>
+                      <a:headEnd type="none" w="med" len="med"/>
+                      <a:tailEnd type="none" w="med" len="med"/>
+                    </a:lnB>
+                    <a:solidFill>
+                      <a:srgbClr val="333333"/>
+                    </a:solidFill>
+                  </a:tcPr>
+                </a:tc>
+                <a:tc>
+                  <a:txBody>
+                    <a:bodyPr/>
+                    <a:lstStyle/>
+                    <a:p>
+                      <a:pPr indent="0" marL="0">
+                        <a:buNone/>
+                      </a:pPr>
+                      <a:r>
+                        <a:rPr lang="en-US" sz="1100" dirty="0">
+                          <a:solidFill>
+                            <a:srgbClr val="F2F2F2"/>
+                          </a:solidFill>
+                          <a:latin typeface="Raleway" pitchFamily="34" charset="0"/>
+                          <a:ea typeface="Raleway" pitchFamily="34" charset="-122"/>
+                          <a:cs typeface="Raleway" pitchFamily="34" charset="-120"/>
+                        </a:rPr>
+                        <a:t>POST /trades/ (userId)</a:t>
+                      </a:r>
+                      <a:endParaRPr lang="en-US" sz="1100" dirty="0">
+                        <a:latin typeface="Raleway" charset="0"/>
+                        <a:ea typeface="Raleway" charset="0"/>
+                        <a:cs typeface="Raleway" charset="0"/>
+                      </a:endParaRPr>
+                    </a:p>
+                  </a:txBody>
+                  <a:tcPr marL="73152" marR="73152" marT="73152" marB="73152" anchor="ctr">
+                    <a:lnL w="12700" cap="flat" cmpd="sng" algn="ctr">
+                      <a:solidFill>
+                        <a:srgbClr val="4A4A4A"/>
+                      </a:solidFill>
+                      <a:prstDash val="solid"/>
+                      <a:round/>
+                      <a:headEnd type="none" w="med" len="med"/>
+                      <a:tailEnd type="none" w="med" len="med"/>
+                    </a:lnL>
+                    <a:lnR w="12700" cap="flat" cmpd="sng" algn="ctr">
+                      <a:solidFill>
+                        <a:srgbClr val="4A4A4A"/>
+                      </a:solidFill>
+                      <a:prstDash val="solid"/>
+                      <a:round/>
+                      <a:headEnd type="none" w="med" len="med"/>
+                      <a:tailEnd type="none" w="med" len="med"/>
+                    </a:lnR>
+                    <a:lnT w="12700" cap="flat" cmpd="sng" algn="ctr">
+                      <a:solidFill>
+                        <a:srgbClr val="4A4A4A"/>
+                      </a:solidFill>
+                      <a:prstDash val="solid"/>
+                      <a:round/>
+                      <a:headEnd type="none" w="med" len="med"/>
+                      <a:tailEnd type="none" w="med" len="med"/>
+                    </a:lnT>
+                    <a:lnB w="12700" cap="flat" cmpd="sng" algn="ctr">
+                      <a:solidFill>
+                        <a:srgbClr val="4A4A4A"/>
+                      </a:solidFill>
+                      <a:prstDash val="solid"/>
+                      <a:round/>
+                      <a:headEnd type="none" w="med" len="med"/>
+                      <a:tailEnd type="none" w="med" len="med"/>
+                    </a:lnB>
+                    <a:solidFill>
+                      <a:srgbClr val="333333"/>
+                    </a:solidFill>
+                  </a:tcPr>
+                </a:tc>
+                <a:tc>
+                  <a:txBody>
+                    <a:bodyPr/>
+                    <a:lstStyle/>
+                    <a:p>
+                      <a:pPr indent="0" marL="0">
+                        <a:buNone/>
+                      </a:pPr>
+                      <a:r>
+                        <a:rPr lang="en-US" sz="1100" dirty="0">
+                          <a:solidFill>
+                            <a:srgbClr val="F2F2F2"/>
+                          </a:solidFill>
+                          <a:latin typeface="Raleway" pitchFamily="34" charset="0"/>
+                          <a:ea typeface="Raleway" pitchFamily="34" charset="-122"/>
+                          <a:cs typeface="Raleway" pitchFamily="34" charset="-120"/>
+                        </a:rPr>
+                        <a:t>Credit to the group and member link, /top</a:t>
+                      </a:r>
+                      <a:endParaRPr lang="en-US" sz="1100" dirty="0">
+                        <a:latin typeface="Raleway" charset="0"/>
+                        <a:ea typeface="Raleway" charset="0"/>
+                        <a:cs typeface="Raleway" charset="0"/>
+                      </a:endParaRPr>
+                    </a:p>
+                  </a:txBody>
+                  <a:tcPr marL="73152" marR="73152" marT="73152" marB="73152" anchor="ctr">
+                    <a:lnL w="12700" cap="flat" cmpd="sng" algn="ctr">
+                      <a:solidFill>
+                        <a:srgbClr val="4A4A4A"/>
+                      </a:solidFill>
+                      <a:prstDash val="solid"/>
+                      <a:round/>
+                      <a:headEnd type="none" w="med" len="med"/>
+                      <a:tailEnd type="none" w="med" len="med"/>
+                    </a:lnL>
+                    <a:lnR w="12700" cap="flat" cmpd="sng" algn="ctr">
+                      <a:solidFill>
+                        <a:srgbClr val="4A4A4A"/>
+                      </a:solidFill>
+                      <a:prstDash val="solid"/>
+                      <a:round/>
+                      <a:headEnd type="none" w="med" len="med"/>
+                      <a:tailEnd type="none" w="med" len="med"/>
+                    </a:lnR>
+                    <a:lnT w="12700" cap="flat" cmpd="sng" algn="ctr">
+                      <a:solidFill>
+                        <a:srgbClr val="4A4A4A"/>
+                      </a:solidFill>
+                      <a:prstDash val="solid"/>
+                      <a:round/>
+                      <a:headEnd type="none" w="med" len="med"/>
+                      <a:tailEnd type="none" w="med" len="med"/>
+                    </a:lnT>
+                    <a:lnB w="12700" cap="flat" cmpd="sng" algn="ctr">
+                      <a:solidFill>
+                        <a:srgbClr val="4A4A4A"/>
+                      </a:solidFill>
+                      <a:prstDash val="solid"/>
+                      <a:round/>
+                      <a:headEnd type="none" w="med" len="med"/>
+                      <a:tailEnd type="none" w="med" len="med"/>
+                    </a:lnB>
+                    <a:solidFill>
+                      <a:srgbClr val="333333"/>
+                    </a:solidFill>
+                  </a:tcPr>
+                </a:tc>
+              </a:tr>
+              <a:tr h="548640">
+                <a:tc>
+                  <a:txBody>
+                    <a:bodyPr/>
+                    <a:lstStyle/>
+                    <a:p>
+                      <a:pPr indent="0" marL="0">
+                        <a:buNone/>
+                      </a:pPr>
+                      <a:r>
+                        <a:rPr lang="en-US" sz="1100" b="1" dirty="0">
+                          <a:solidFill>
+                            <a:srgbClr val="FFFFFF"/>
+                          </a:solidFill>
+                          <a:latin typeface="Raleway" pitchFamily="34" charset="0"/>
+                          <a:ea typeface="Raleway" pitchFamily="34" charset="-122"/>
+                          <a:cs typeface="Raleway" pitchFamily="34" charset="-120"/>
+                        </a:rPr>
+                        <a:t>Market creation</a:t>
+                      </a:r>
+                      <a:endParaRPr lang="en-US" sz="1100" dirty="0">
+                        <a:latin typeface="Raleway" charset="0"/>
+                        <a:ea typeface="Raleway" charset="0"/>
+                        <a:cs typeface="Raleway" charset="0"/>
+                      </a:endParaRPr>
+                    </a:p>
+                  </a:txBody>
+                  <a:tcPr marL="73152" marR="73152" marT="73152" marB="73152" anchor="ctr">
+                    <a:lnL w="12700" cap="flat" cmpd="sng" algn="ctr">
+                      <a:solidFill>
+                        <a:srgbClr val="4A4A4A"/>
+                      </a:solidFill>
+                      <a:prstDash val="solid"/>
+                      <a:round/>
+                      <a:headEnd type="none" w="med" len="med"/>
+                      <a:tailEnd type="none" w="med" len="med"/>
+                    </a:lnL>
+                    <a:lnR w="12700" cap="flat" cmpd="sng" algn="ctr">
+                      <a:solidFill>
+                        <a:srgbClr val="4A4A4A"/>
+                      </a:solidFill>
+                      <a:prstDash val="solid"/>
+                      <a:round/>
+                      <a:headEnd type="none" w="med" len="med"/>
+                      <a:tailEnd type="none" w="med" len="med"/>
+                    </a:lnR>
+                    <a:lnT w="12700" cap="flat" cmpd="sng" algn="ctr">
+                      <a:solidFill>
+                        <a:srgbClr val="4A4A4A"/>
+                      </a:solidFill>
+                      <a:prstDash val="solid"/>
+                      <a:round/>
+                      <a:headEnd type="none" w="med" len="med"/>
+                      <a:tailEnd type="none" w="med" len="med"/>
+                    </a:lnT>
+                    <a:lnB w="12700" cap="flat" cmpd="sng" algn="ctr">
+                      <a:solidFill>
+                        <a:srgbClr val="4A4A4A"/>
+                      </a:solidFill>
+                      <a:prstDash val="solid"/>
+                      <a:round/>
+                      <a:headEnd type="none" w="med" len="med"/>
+                      <a:tailEnd type="none" w="med" len="med"/>
+                    </a:lnB>
+                    <a:solidFill>
+                      <a:srgbClr val="262626"/>
+                    </a:solidFill>
+                  </a:tcPr>
+                </a:tc>
+                <a:tc>
+                  <a:txBody>
+                    <a:bodyPr/>
+                    <a:lstStyle/>
+                    <a:p>
+                      <a:pPr indent="0" marL="0">
+                        <a:buNone/>
+                      </a:pPr>
+                      <a:r>
+                        <a:rPr lang="en-US" sz="1100" dirty="0">
+                          <a:solidFill>
+                            <a:srgbClr val="F2F2F2"/>
+                          </a:solidFill>
+                          <a:latin typeface="Raleway" pitchFamily="34" charset="0"/>
+                          <a:ea typeface="Raleway" pitchFamily="34" charset="-122"/>
+                          <a:cs typeface="Raleway" pitchFamily="34" charset="-120"/>
+                        </a:rPr>
+                        <a:t>markets/create/quote → build → register</a:t>
+                      </a:r>
+                      <a:endParaRPr lang="en-US" sz="1100" dirty="0">
+                        <a:latin typeface="Raleway" charset="0"/>
+                        <a:ea typeface="Raleway" charset="0"/>
+                        <a:cs typeface="Raleway" charset="0"/>
+                      </a:endParaRPr>
+                    </a:p>
+                  </a:txBody>
+                  <a:tcPr marL="73152" marR="73152" marT="73152" marB="73152" anchor="ctr">
+                    <a:lnL w="12700" cap="flat" cmpd="sng" algn="ctr">
+                      <a:solidFill>
+                        <a:srgbClr val="4A4A4A"/>
+                      </a:solidFill>
+                      <a:prstDash val="solid"/>
+                      <a:round/>
+                      <a:headEnd type="none" w="med" len="med"/>
+                      <a:tailEnd type="none" w="med" len="med"/>
+                    </a:lnL>
+                    <a:lnR w="12700" cap="flat" cmpd="sng" algn="ctr">
+                      <a:solidFill>
+                        <a:srgbClr val="4A4A4A"/>
+                      </a:solidFill>
+                      <a:prstDash val="solid"/>
+                      <a:round/>
+                      <a:headEnd type="none" w="med" len="med"/>
+                      <a:tailEnd type="none" w="med" len="med"/>
+                    </a:lnR>
+                    <a:lnT w="12700" cap="flat" cmpd="sng" algn="ctr">
+                      <a:solidFill>
+                        <a:srgbClr val="4A4A4A"/>
+                      </a:solidFill>
+                      <a:prstDash val="solid"/>
+                      <a:round/>
+                      <a:headEnd type="none" w="med" len="med"/>
+                      <a:tailEnd type="none" w="med" len="med"/>
+                    </a:lnT>
+                    <a:lnB w="12700" cap="flat" cmpd="sng" algn="ctr">
+                      <a:solidFill>
+                        <a:srgbClr val="4A4A4A"/>
+                      </a:solidFill>
+                      <a:prstDash val="solid"/>
+                      <a:round/>
+                      <a:headEnd type="none" w="med" len="med"/>
+                      <a:tailEnd type="none" w="med" len="med"/>
+                    </a:lnB>
+                    <a:solidFill>
+                      <a:srgbClr val="262626"/>
+                    </a:solidFill>
+                  </a:tcPr>
+                </a:tc>
+                <a:tc>
+                  <a:txBody>
+                    <a:bodyPr/>
+                    <a:lstStyle/>
+                    <a:p>
+                      <a:pPr indent="0" marL="0">
+                        <a:buNone/>
+                      </a:pPr>
+                      <a:r>
+                        <a:rPr lang="en-US" sz="1100" dirty="0">
+                          <a:solidFill>
+                            <a:srgbClr val="F2F2F2"/>
+                          </a:solidFill>
+                          <a:latin typeface="Raleway" pitchFamily="34" charset="0"/>
+                          <a:ea typeface="Raleway" pitchFamily="34" charset="-122"/>
+                          <a:cs typeface="Raleway" pitchFamily="34" charset="-120"/>
+                        </a:rPr>
+                        <a:t>Admin taps Create; fee checked against $20 / $50</a:t>
+                      </a:r>
+                      <a:endParaRPr lang="en-US" sz="1100" dirty="0">
+                        <a:latin typeface="Raleway" charset="0"/>
+                        <a:ea typeface="Raleway" charset="0"/>
+                        <a:cs typeface="Raleway" charset="0"/>
+                      </a:endParaRPr>
+                    </a:p>
+                  </a:txBody>
+                  <a:tcPr marL="73152" marR="73152" marT="73152" marB="73152" anchor="ctr">
+                    <a:lnL w="12700" cap="flat" cmpd="sng" algn="ctr">
+                      <a:solidFill>
+                        <a:srgbClr val="4A4A4A"/>
+                      </a:solidFill>
+                      <a:prstDash val="solid"/>
+                      <a:round/>
+                      <a:headEnd type="none" w="med" len="med"/>
+                      <a:tailEnd type="none" w="med" len="med"/>
+                    </a:lnL>
+                    <a:lnR w="12700" cap="flat" cmpd="sng" algn="ctr">
+                      <a:solidFill>
+                        <a:srgbClr val="4A4A4A"/>
+                      </a:solidFill>
+                      <a:prstDash val="solid"/>
+                      <a:round/>
+                      <a:headEnd type="none" w="med" len="med"/>
+                      <a:tailEnd type="none" w="med" len="med"/>
+                    </a:lnR>
+                    <a:lnT w="12700" cap="flat" cmpd="sng" algn="ctr">
+                      <a:solidFill>
+                        <a:srgbClr val="4A4A4A"/>
+                      </a:solidFill>
+                      <a:prstDash val="solid"/>
+                      <a:round/>
+                      <a:headEnd type="none" w="med" len="med"/>
+                      <a:tailEnd type="none" w="med" len="med"/>
+                    </a:lnT>
+                    <a:lnB w="12700" cap="flat" cmpd="sng" algn="ctr">
+                      <a:solidFill>
+                        <a:srgbClr val="4A4A4A"/>
+                      </a:solidFill>
+                      <a:prstDash val="solid"/>
+                      <a:round/>
+                      <a:headEnd type="none" w="med" len="med"/>
+                      <a:tailEnd type="none" w="med" len="med"/>
+                    </a:lnB>
+                    <a:solidFill>
+                      <a:srgbClr val="262626"/>
+                    </a:solidFill>
+                  </a:tcPr>
+                </a:tc>
+              </a:tr>
+              <a:tr h="548640">
+                <a:tc>
+                  <a:txBody>
+                    <a:bodyPr/>
+                    <a:lstStyle/>
+                    <a:p>
+                      <a:pPr indent="0" marL="0">
+                        <a:buNone/>
+                      </a:pPr>
+                      <a:r>
+                        <a:rPr lang="en-US" sz="1100" b="1" dirty="0">
+                          <a:solidFill>
+                            <a:srgbClr val="FFFFFF"/>
+                          </a:solidFill>
+                          <a:latin typeface="Raleway" pitchFamily="34" charset="0"/>
+                          <a:ea typeface="Raleway" pitchFamily="34" charset="-122"/>
+                          <a:cs typeface="Raleway" pitchFamily="34" charset="-120"/>
+                        </a:rPr>
+                        <a:t>Claims</a:t>
+                      </a:r>
+                      <a:endParaRPr lang="en-US" sz="1100" dirty="0">
+                        <a:latin typeface="Raleway" charset="0"/>
+                        <a:ea typeface="Raleway" charset="0"/>
+                        <a:cs typeface="Raleway" charset="0"/>
+                      </a:endParaRPr>
+                    </a:p>
+                  </a:txBody>
+                  <a:tcPr marL="73152" marR="73152" marT="73152" marB="73152" anchor="ctr">
+                    <a:lnL w="12700" cap="flat" cmpd="sng" algn="ctr">
+                      <a:solidFill>
+                        <a:srgbClr val="4A4A4A"/>
+                      </a:solidFill>
+                      <a:prstDash val="solid"/>
+                      <a:round/>
+                      <a:headEnd type="none" w="med" len="med"/>
+                      <a:tailEnd type="none" w="med" len="med"/>
+                    </a:lnL>
+                    <a:lnR w="12700" cap="flat" cmpd="sng" algn="ctr">
+                      <a:solidFill>
+                        <a:srgbClr val="4A4A4A"/>
+                      </a:solidFill>
+                      <a:prstDash val="solid"/>
+                      <a:round/>
+                      <a:headEnd type="none" w="med" len="med"/>
+                      <a:tailEnd type="none" w="med" len="med"/>
+                    </a:lnR>
+                    <a:lnT w="12700" cap="flat" cmpd="sng" algn="ctr">
+                      <a:solidFill>
+                        <a:srgbClr val="4A4A4A"/>
+                      </a:solidFill>
+                      <a:prstDash val="solid"/>
+                      <a:round/>
+                      <a:headEnd type="none" w="med" len="med"/>
+                      <a:tailEnd type="none" w="med" len="med"/>
+                    </a:lnT>
+                    <a:lnB w="12700" cap="flat" cmpd="sng" algn="ctr">
+                      <a:solidFill>
+                        <a:srgbClr val="4A4A4A"/>
+                      </a:solidFill>
+                      <a:prstDash val="solid"/>
+                      <a:round/>
+                      <a:headEnd type="none" w="med" len="med"/>
+                      <a:tailEnd type="none" w="med" len="med"/>
+                    </a:lnB>
+                    <a:solidFill>
+                      <a:srgbClr val="333333"/>
+                    </a:solidFill>
+                  </a:tcPr>
+                </a:tc>
+                <a:tc>
+                  <a:txBody>
+                    <a:bodyPr/>
+                    <a:lstStyle/>
+                    <a:p>
+                      <a:pPr indent="0" marL="0">
+                        <a:buNone/>
+                      </a:pPr>
+                      <a:r>
+                        <a:rPr lang="en-US" sz="1100" dirty="0">
+                          <a:solidFill>
+                            <a:srgbClr val="F2F2F2"/>
+                          </a:solidFill>
+                          <a:latin typeface="Raleway" pitchFamily="34" charset="0"/>
+                          <a:ea typeface="Raleway" pitchFamily="34" charset="-122"/>
+                          <a:cs typeface="Raleway" pitchFamily="34" charset="-120"/>
+                        </a:rPr>
+                        <a:t>claim/build · claim/creator-fees/build</a:t>
+                      </a:r>
+                      <a:endParaRPr lang="en-US" sz="1100" dirty="0">
+                        <a:latin typeface="Raleway" charset="0"/>
+                        <a:ea typeface="Raleway" charset="0"/>
+                        <a:cs typeface="Raleway" charset="0"/>
+                      </a:endParaRPr>
+                    </a:p>
+                  </a:txBody>
+                  <a:tcPr marL="73152" marR="73152" marT="73152" marB="73152" anchor="ctr">
+                    <a:lnL w="12700" cap="flat" cmpd="sng" algn="ctr">
+                      <a:solidFill>
+                        <a:srgbClr val="4A4A4A"/>
+                      </a:solidFill>
+                      <a:prstDash val="solid"/>
+                      <a:round/>
+                      <a:headEnd type="none" w="med" len="med"/>
+                      <a:tailEnd type="none" w="med" len="med"/>
+                    </a:lnL>
+                    <a:lnR w="12700" cap="flat" cmpd="sng" algn="ctr">
+                      <a:solidFill>
+                        <a:srgbClr val="4A4A4A"/>
+                      </a:solidFill>
+                      <a:prstDash val="solid"/>
+                      <a:round/>
+                      <a:headEnd type="none" w="med" len="med"/>
+                      <a:tailEnd type="none" w="med" len="med"/>
+                    </a:lnR>
+                    <a:lnT w="12700" cap="flat" cmpd="sng" algn="ctr">
+                      <a:solidFill>
+                        <a:srgbClr val="4A4A4A"/>
+                      </a:solidFill>
+                      <a:prstDash val="solid"/>
+                      <a:round/>
+                      <a:headEnd type="none" w="med" len="med"/>
+                      <a:tailEnd type="none" w="med" len="med"/>
+                    </a:lnT>
+                    <a:lnB w="12700" cap="flat" cmpd="sng" algn="ctr">
+                      <a:solidFill>
+                        <a:srgbClr val="4A4A4A"/>
+                      </a:solidFill>
+                      <a:prstDash val="solid"/>
+                      <a:round/>
+                      <a:headEnd type="none" w="med" len="med"/>
+                      <a:tailEnd type="none" w="med" len="med"/>
+                    </a:lnB>
+                    <a:solidFill>
+                      <a:srgbClr val="333333"/>
+                    </a:solidFill>
+                  </a:tcPr>
+                </a:tc>
+                <a:tc>
+                  <a:txBody>
+                    <a:bodyPr/>
+                    <a:lstStyle/>
+                    <a:p>
+                      <a:pPr indent="0" marL="0">
+                        <a:buNone/>
+                      </a:pPr>
+                      <a:r>
+                        <a:rPr lang="en-US" sz="1100" dirty="0">
+                          <a:solidFill>
+                            <a:srgbClr val="F2F2F2"/>
+                          </a:solidFill>
+                          <a:latin typeface="Raleway" pitchFamily="34" charset="0"/>
+                          <a:ea typeface="Raleway" pitchFamily="34" charset="-122"/>
+                          <a:cs typeface="Raleway" pitchFamily="34" charset="-120"/>
+                        </a:rPr>
+                        <a:t>Winnings and the community owner's creator cut</a:t>
+                      </a:r>
+                      <a:endParaRPr lang="en-US" sz="1100" dirty="0">
+                        <a:latin typeface="Raleway" charset="0"/>
+                        <a:ea typeface="Raleway" charset="0"/>
+                        <a:cs typeface="Raleway" charset="0"/>
+                      </a:endParaRPr>
+                    </a:p>
+                  </a:txBody>
+                  <a:tcPr marL="73152" marR="73152" marT="73152" marB="73152" anchor="ctr">
+                    <a:lnL w="12700" cap="flat" cmpd="sng" algn="ctr">
+                      <a:solidFill>
+                        <a:srgbClr val="4A4A4A"/>
+                      </a:solidFill>
+                      <a:prstDash val="solid"/>
+                      <a:round/>
+                      <a:headEnd type="none" w="med" len="med"/>
+                      <a:tailEnd type="none" w="med" len="med"/>
+                    </a:lnL>
+                    <a:lnR w="12700" cap="flat" cmpd="sng" algn="ctr">
+                      <a:solidFill>
+                        <a:srgbClr val="4A4A4A"/>
+                      </a:solidFill>
+                      <a:prstDash val="solid"/>
+                      <a:round/>
+                      <a:headEnd type="none" w="med" len="med"/>
+                      <a:tailEnd type="none" w="med" len="med"/>
+                    </a:lnR>
+                    <a:lnT w="12700" cap="flat" cmpd="sng" algn="ctr">
+                      <a:solidFill>
+                        <a:srgbClr val="4A4A4A"/>
+                      </a:solidFill>
+                      <a:prstDash val="solid"/>
+                      <a:round/>
+                      <a:headEnd type="none" w="med" len="med"/>
+                      <a:tailEnd type="none" w="med" len="med"/>
+                    </a:lnT>
+                    <a:lnB w="12700" cap="flat" cmpd="sng" algn="ctr">
+                      <a:solidFill>
+                        <a:srgbClr val="4A4A4A"/>
+                      </a:solidFill>
+                      <a:prstDash val="solid"/>
+                      <a:round/>
+                      <a:headEnd type="none" w="med" len="med"/>
+                      <a:tailEnd type="none" w="med" len="med"/>
+                    </a:lnB>
+                    <a:solidFill>
+                      <a:srgbClr val="333333"/>
                     </a:solidFill>
                   </a:tcPr>
                 </a:tc>
@@ -7308,6 +8248,9 @@
               </a:rPr>
               <a:t>POT</a:t>
             </a:r>
+            <a:pPr indent="0" marL="0">
+              <a:buNone/>
+            </a:pPr>
             <a:r>
               <a:rPr lang="en-US" sz="1100" dirty="0">
                 <a:solidFill>
@@ -7436,6 +8379,9 @@
               </a:rPr>
               <a:t>Every Telegram group becomes a </a:t>
             </a:r>
+            <a:pPr indent="0" marL="0">
+              <a:buNone/>
+            </a:pPr>
             <a:r>
               <a:rPr lang="en-US" sz="3400" dirty="0">
                 <a:solidFill>
@@ -7506,7 +8452,7 @@
                 <a:ea typeface="Raleway" pitchFamily="34" charset="-122"/>
                 <a:cs typeface="Raleway" pitchFamily="34" charset="-120"/>
               </a:rPr>
-              <a:t>Football fan groups</a:t>
+              <a:t>BBNaija and reality-TV fans</a:t>
             </a:r>
             <a:endParaRPr lang="en-US" sz="1500" dirty="0"/>
           </a:p>
@@ -7567,7 +8513,7 @@
                 <a:ea typeface="Raleway" pitchFamily="34" charset="-122"/>
                 <a:cs typeface="Raleway" pitchFamily="34" charset="-120"/>
               </a:rPr>
-              <a:t>Crypto trading chats</a:t>
+              <a:t>Music and movie stans</a:t>
             </a:r>
             <a:endParaRPr lang="en-US" sz="1500" dirty="0"/>
           </a:p>
@@ -7628,7 +8574,7 @@
                 <a:ea typeface="Raleway" pitchFamily="34" charset="-122"/>
                 <a:cs typeface="Raleway" pitchFamily="34" charset="-120"/>
               </a:rPr>
-              <a:t>Campus and church groups</a:t>
+              <a:t>Football and politics chats</a:t>
             </a:r>
             <a:endParaRPr lang="en-US" sz="1500" dirty="0"/>
           </a:p>
@@ -8210,7 +9156,7 @@
                 <a:ea typeface="Raleway" pitchFamily="34" charset="-122"/>
                 <a:cs typeface="Raleway" pitchFamily="34" charset="-120"/>
               </a:rPr>
-              <a:t>Pot doesn't compete with Panta's website. It brings people to Panta from where they already spend time.</a:t>
+              <a:t>Pot gives Panta distribution: it brings people to Panta from the chats where the debates already happen. Community owners earn the creator's cut.</a:t>
             </a:r>
             <a:endParaRPr lang="en-US" sz="1400" dirty="0"/>
           </a:p>
@@ -8283,6 +9229,9 @@
               </a:rPr>
               <a:t>POT</a:t>
             </a:r>
+            <a:pPr indent="0" marL="0">
+              <a:buNone/>
+            </a:pPr>
             <a:r>
               <a:rPr lang="en-US" sz="1100" dirty="0">
                 <a:solidFill>
@@ -8401,7 +9350,7 @@
               <a:buNone/>
             </a:pPr>
             <a:r>
-              <a:rPr lang="en-US" sz="3000" dirty="0">
+              <a:rPr lang="en-US" sz="2800" dirty="0">
                 <a:solidFill>
                   <a:srgbClr val="FFFFFF"/>
                 </a:solidFill>
@@ -8409,10 +9358,13 @@
                 <a:ea typeface="Russo One" pitchFamily="34" charset="-122"/>
                 <a:cs typeface="Russo One" pitchFamily="34" charset="-120"/>
               </a:rPr>
-              <a:t>Practice mode today. </a:t>
-            </a:r>
-            <a:r>
-              <a:rPr lang="en-US" sz="3000" dirty="0">
+              <a:t>An honest sandbox submission. </a:t>
+            </a:r>
+            <a:pPr indent="0" marL="0">
+              <a:buNone/>
+            </a:pPr>
+            <a:r>
+              <a:rPr lang="en-US" sz="2800" dirty="0">
                 <a:solidFill>
                   <a:srgbClr val="FFD101"/>
                 </a:solidFill>
@@ -8420,9 +9372,9 @@
                 <a:ea typeface="Russo One" pitchFamily="34" charset="-122"/>
                 <a:cs typeface="Russo One" pitchFamily="34" charset="-120"/>
               </a:rPr>
-              <a:t>Live mode is one command away.</a:t>
-            </a:r>
-            <a:endParaRPr lang="en-US" sz="3000" dirty="0"/>
+              <a:t>Live is one switch away.</a:t>
+            </a:r>
+            <a:endParaRPr lang="en-US" sz="2800" dirty="0"/>
           </a:p>
         </p:txBody>
       </p:sp>
@@ -8453,7 +9405,7 @@
                 <a:gridCol w="2788920"/>
                 <a:gridCol w="2788920"/>
               </a:tblGrid>
-              <a:tr h="566928">
+              <a:tr h="512064">
                 <a:tc>
                   <a:txBody>
                     <a:bodyPr/>
@@ -8648,7 +9600,7 @@
                   </a:tcPr>
                 </a:tc>
               </a:tr>
-              <a:tr h="566928">
+              <a:tr h="512064">
                 <a:tc>
                   <a:txBody>
                     <a:bodyPr/>
@@ -8854,7 +9806,7 @@
                   </a:tcPr>
                 </a:tc>
               </a:tr>
-              <a:tr h="566928">
+              <a:tr h="512064">
                 <a:tc>
                   <a:txBody>
                     <a:bodyPr/>
@@ -9060,7 +10012,7 @@
                   </a:tcPr>
                 </a:tc>
               </a:tr>
-              <a:tr h="566928">
+              <a:tr h="512064">
                 <a:tc>
                   <a:txBody>
                     <a:bodyPr/>
@@ -9266,7 +10218,213 @@
                   </a:tcPr>
                 </a:tc>
               </a:tr>
-              <a:tr h="566928">
+              <a:tr h="512064">
+                <a:tc>
+                  <a:txBody>
+                    <a:bodyPr/>
+                    <a:lstStyle/>
+                    <a:p>
+                      <a:pPr indent="0" marL="0">
+                        <a:buNone/>
+                      </a:pPr>
+                      <a:r>
+                        <a:rPr lang="en-US" sz="1200" b="1" dirty="0">
+                          <a:solidFill>
+                            <a:srgbClr val="FFFFFF"/>
+                          </a:solidFill>
+                          <a:latin typeface="Raleway" pitchFamily="34" charset="0"/>
+                          <a:ea typeface="Raleway" pitchFamily="34" charset="-122"/>
+                          <a:cs typeface="Raleway" pitchFamily="34" charset="-120"/>
+                        </a:rPr>
+                        <a:t>Panta data</a:t>
+                      </a:r>
+                      <a:endParaRPr lang="en-US" sz="1200" dirty="0">
+                        <a:latin typeface="Raleway" charset="0"/>
+                        <a:ea typeface="Raleway" charset="0"/>
+                        <a:cs typeface="Raleway" charset="0"/>
+                      </a:endParaRPr>
+                    </a:p>
+                  </a:txBody>
+                  <a:tcPr marL="91440" marR="91440" marT="91440" marB="91440" anchor="ctr">
+                    <a:lnL w="12700" cap="flat" cmpd="sng" algn="ctr">
+                      <a:solidFill>
+                        <a:srgbClr val="4A4A4A"/>
+                      </a:solidFill>
+                      <a:prstDash val="solid"/>
+                      <a:round/>
+                      <a:headEnd type="none" w="med" len="med"/>
+                      <a:tailEnd type="none" w="med" len="med"/>
+                    </a:lnL>
+                    <a:lnR w="12700" cap="flat" cmpd="sng" algn="ctr">
+                      <a:solidFill>
+                        <a:srgbClr val="4A4A4A"/>
+                      </a:solidFill>
+                      <a:prstDash val="solid"/>
+                      <a:round/>
+                      <a:headEnd type="none" w="med" len="med"/>
+                      <a:tailEnd type="none" w="med" len="med"/>
+                    </a:lnR>
+                    <a:lnT w="12700" cap="flat" cmpd="sng" algn="ctr">
+                      <a:solidFill>
+                        <a:srgbClr val="4A4A4A"/>
+                      </a:solidFill>
+                      <a:prstDash val="solid"/>
+                      <a:round/>
+                      <a:headEnd type="none" w="med" len="med"/>
+                      <a:tailEnd type="none" w="med" len="med"/>
+                    </a:lnT>
+                    <a:lnB w="12700" cap="flat" cmpd="sng" algn="ctr">
+                      <a:solidFill>
+                        <a:srgbClr val="4A4A4A"/>
+                      </a:solidFill>
+                      <a:prstDash val="solid"/>
+                      <a:round/>
+                      <a:headEnd type="none" w="med" len="med"/>
+                      <a:tailEnd type="none" w="med" len="med"/>
+                    </a:lnB>
+                    <a:solidFill>
+                      <a:srgbClr val="333333"/>
+                    </a:solidFill>
+                  </a:tcPr>
+                </a:tc>
+                <a:tc>
+                  <a:txBody>
+                    <a:bodyPr/>
+                    <a:lstStyle/>
+                    <a:p>
+                      <a:pPr indent="0" marL="0">
+                        <a:buNone/>
+                      </a:pPr>
+                      <a:r>
+                        <a:rPr lang="en-US" sz="1200" dirty="0">
+                          <a:solidFill>
+                            <a:srgbClr val="F2F2F2"/>
+                          </a:solidFill>
+                          <a:latin typeface="Raleway" pitchFamily="34" charset="0"/>
+                          <a:ea typeface="Raleway" pitchFamily="34" charset="-122"/>
+                          <a:cs typeface="Raleway" pitchFamily="34" charset="-120"/>
+                        </a:rPr>
+                        <a:t>Real live Panta markets and prices in the chat (/panta)</a:t>
+                      </a:r>
+                      <a:endParaRPr lang="en-US" sz="1200" dirty="0">
+                        <a:latin typeface="Raleway" charset="0"/>
+                        <a:ea typeface="Raleway" charset="0"/>
+                        <a:cs typeface="Raleway" charset="0"/>
+                      </a:endParaRPr>
+                    </a:p>
+                  </a:txBody>
+                  <a:tcPr marL="91440" marR="91440" marT="91440" marB="91440" anchor="ctr">
+                    <a:lnL w="12700" cap="flat" cmpd="sng" algn="ctr">
+                      <a:solidFill>
+                        <a:srgbClr val="4A4A4A"/>
+                      </a:solidFill>
+                      <a:prstDash val="solid"/>
+                      <a:round/>
+                      <a:headEnd type="none" w="med" len="med"/>
+                      <a:tailEnd type="none" w="med" len="med"/>
+                    </a:lnL>
+                    <a:lnR w="12700" cap="flat" cmpd="sng" algn="ctr">
+                      <a:solidFill>
+                        <a:srgbClr val="4A4A4A"/>
+                      </a:solidFill>
+                      <a:prstDash val="solid"/>
+                      <a:round/>
+                      <a:headEnd type="none" w="med" len="med"/>
+                      <a:tailEnd type="none" w="med" len="med"/>
+                    </a:lnR>
+                    <a:lnT w="12700" cap="flat" cmpd="sng" algn="ctr">
+                      <a:solidFill>
+                        <a:srgbClr val="4A4A4A"/>
+                      </a:solidFill>
+                      <a:prstDash val="solid"/>
+                      <a:round/>
+                      <a:headEnd type="none" w="med" len="med"/>
+                      <a:tailEnd type="none" w="med" len="med"/>
+                    </a:lnT>
+                    <a:lnB w="12700" cap="flat" cmpd="sng" algn="ctr">
+                      <a:solidFill>
+                        <a:srgbClr val="4A4A4A"/>
+                      </a:solidFill>
+                      <a:prstDash val="solid"/>
+                      <a:round/>
+                      <a:headEnd type="none" w="med" len="med"/>
+                      <a:tailEnd type="none" w="med" len="med"/>
+                    </a:lnB>
+                    <a:solidFill>
+                      <a:srgbClr val="333333"/>
+                    </a:solidFill>
+                  </a:tcPr>
+                </a:tc>
+                <a:tc>
+                  <a:txBody>
+                    <a:bodyPr/>
+                    <a:lstStyle/>
+                    <a:p>
+                      <a:pPr indent="0" marL="0">
+                        <a:buNone/>
+                      </a:pPr>
+                      <a:r>
+                        <a:rPr lang="en-US" sz="1200" dirty="0">
+                          <a:solidFill>
+                            <a:srgbClr val="F2F2F2"/>
+                          </a:solidFill>
+                          <a:latin typeface="Raleway" pitchFamily="34" charset="0"/>
+                          <a:ea typeface="Raleway" pitchFamily="34" charset="-122"/>
+                          <a:cs typeface="Raleway" pitchFamily="34" charset="-120"/>
+                        </a:rPr>
+                        <a:t>Same, plus buys on them</a:t>
+                      </a:r>
+                      <a:endParaRPr lang="en-US" sz="1200" dirty="0">
+                        <a:latin typeface="Raleway" charset="0"/>
+                        <a:ea typeface="Raleway" charset="0"/>
+                        <a:cs typeface="Raleway" charset="0"/>
+                      </a:endParaRPr>
+                    </a:p>
+                  </a:txBody>
+                  <a:tcPr marL="91440" marR="91440" marT="91440" marB="91440" anchor="ctr">
+                    <a:lnL w="12700" cap="flat" cmpd="sng" algn="ctr">
+                      <a:solidFill>
+                        <a:srgbClr val="4A4A4A"/>
+                      </a:solidFill>
+                      <a:prstDash val="solid"/>
+                      <a:round/>
+                      <a:headEnd type="none" w="med" len="med"/>
+                      <a:tailEnd type="none" w="med" len="med"/>
+                    </a:lnL>
+                    <a:lnR w="12700" cap="flat" cmpd="sng" algn="ctr">
+                      <a:solidFill>
+                        <a:srgbClr val="4A4A4A"/>
+                      </a:solidFill>
+                      <a:prstDash val="solid"/>
+                      <a:round/>
+                      <a:headEnd type="none" w="med" len="med"/>
+                      <a:tailEnd type="none" w="med" len="med"/>
+                    </a:lnR>
+                    <a:lnT w="12700" cap="flat" cmpd="sng" algn="ctr">
+                      <a:solidFill>
+                        <a:srgbClr val="4A4A4A"/>
+                      </a:solidFill>
+                      <a:prstDash val="solid"/>
+                      <a:round/>
+                      <a:headEnd type="none" w="med" len="med"/>
+                      <a:tailEnd type="none" w="med" len="med"/>
+                    </a:lnT>
+                    <a:lnB w="12700" cap="flat" cmpd="sng" algn="ctr">
+                      <a:solidFill>
+                        <a:srgbClr val="4A4A4A"/>
+                      </a:solidFill>
+                      <a:prstDash val="solid"/>
+                      <a:round/>
+                      <a:headEnd type="none" w="med" len="med"/>
+                      <a:tailEnd type="none" w="med" len="med"/>
+                    </a:lnB>
+                    <a:solidFill>
+                      <a:srgbClr val="333333"/>
+                    </a:solidFill>
+                  </a:tcPr>
+                </a:tc>
+              </a:tr>
+              <a:tr h="512064">
                 <a:tc>
                   <a:txBody>
                     <a:bodyPr/>
@@ -9331,7 +10489,7 @@
                       <a:tailEnd type="none" w="med" len="med"/>
                     </a:lnB>
                     <a:solidFill>
-                      <a:srgbClr val="333333"/>
+                      <a:srgbClr val="262626"/>
                     </a:solidFill>
                   </a:tcPr>
                 </a:tc>
@@ -9352,7 +10510,7 @@
                           <a:ea typeface="Raleway" pitchFamily="34" charset="-122"/>
                           <a:cs typeface="Raleway" pitchFamily="34" charset="-120"/>
                         </a:rPr>
-                        <a:t>Real people, real groups, real phones</a:t>
+                        <a:t>Sandbox end-to-end script; real groups and phones</a:t>
                       </a:r>
                       <a:endParaRPr lang="en-US" sz="1200" dirty="0">
                         <a:latin typeface="Raleway" charset="0"/>
@@ -9399,7 +10557,7 @@
                       <a:tailEnd type="none" w="med" len="med"/>
                     </a:lnB>
                     <a:solidFill>
-                      <a:srgbClr val="333333"/>
+                      <a:srgbClr val="262626"/>
                     </a:solidFill>
                   </a:tcPr>
                 </a:tc>
@@ -9420,7 +10578,7 @@
                           <a:ea typeface="Raleway" pitchFamily="34" charset="-122"/>
                           <a:cs typeface="Raleway" pitchFamily="34" charset="-120"/>
                         </a:rPr>
-                        <a:t>Read-only calls to Panta's live API</a:t>
+                        <a:t>Read-only live probe (live-probe.mts)</a:t>
                       </a:r>
                       <a:endParaRPr lang="en-US" sz="1200" dirty="0">
                         <a:latin typeface="Raleway" charset="0"/>
@@ -9467,7 +10625,7 @@
                       <a:tailEnd type="none" w="med" len="med"/>
                     </a:lnB>
                     <a:solidFill>
-                      <a:srgbClr val="333333"/>
+                      <a:srgbClr val="262626"/>
                     </a:solidFill>
                   </a:tcPr>
                 </a:tc>
@@ -9484,8 +10642,8 @@
         </p:nvSpPr>
         <p:spPr>
           <a:xfrm>
-            <a:off x="548640" y="5120640"/>
-            <a:ext cx="6766560" cy="274320"/>
+            <a:off x="548640" y="5349240"/>
+            <a:ext cx="6766560" cy="457200"/>
           </a:xfrm>
           <a:prstGeom prst="rect">
             <a:avLst/>
@@ -9509,7 +10667,7 @@
                 <a:ea typeface="Raleway" pitchFamily="34" charset="-122"/>
                 <a:cs typeface="Raleway" pitchFamily="34" charset="-120"/>
               </a:rPr>
-              <a:t>Switch: scripts/go-live.sh · Back: scripts/rollback-to-practice.sh</a:t>
+              <a:t>One switch: scripts/go-live.sh (GO-LIVE.md) · back: scripts/rollback-to-practice.sh. The demo video shows the live flow at launch.</a:t>
             </a:r>
             <a:endParaRPr lang="en-US" sz="1200" dirty="0"/>
           </a:p>
@@ -9576,7 +10734,7 @@
       </p:sp>
       <p:sp>
         <p:nvSpPr>
-          <p:cNvPr id="19" name="Text 7"/>
+          <p:cNvPr id="10" name="Text 7"/>
           <p:cNvSpPr/>
           <p:nvPr/>
         </p:nvSpPr>

</xml_diff>